<commit_message>
Simplify Mailpit architecture: remove ALB, CloudFront direct to EC2
ALB is unnecessary for a single-instance test tool. CloudFront uses the
Elastic IP as a custom HTTP origin on port 8025 directly. Security group
now uses CloudFront managed prefix list (SourcePrefixListId) for port 8025
so WAF cannot be bypassed via direct IP access. SMTP port 1025 uses an
internal CIDR for app servers under test.
</commit_message>
<xml_diff>
--- a/infrastructure/mailpit/Mailpit_Architecture_Update.pptx
+++ b/infrastructure/mailpit/Mailpit_Architecture_Update.pptx
@@ -3143,8 +3143,8 @@
         </p:nvSpPr>
         <p:spPr>
           <a:xfrm>
-            <a:off x="914400" y="1371600"/>
-            <a:ext cx="10360152" cy="1097280"/>
+            <a:off x="914400" y="1463040"/>
+            <a:ext cx="10360152" cy="1005840"/>
           </a:xfrm>
           <a:prstGeom prst="rect">
             <a:avLst/>
@@ -3177,8 +3177,8 @@
         </p:nvSpPr>
         <p:spPr>
           <a:xfrm>
-            <a:off x="914400" y="2560320"/>
-            <a:ext cx="10360152" cy="640080"/>
+            <a:off x="914400" y="2606040"/>
+            <a:ext cx="10360152" cy="594360"/>
           </a:xfrm>
           <a:prstGeom prst="rect">
             <a:avLst/>
@@ -3193,12 +3193,12 @@
           <a:p>
             <a:pPr algn="ctr"/>
             <a:r>
-              <a:rPr sz="2000" b="0">
+              <a:rPr sz="1800" b="0">
                 <a:solidFill>
                   <a:srgbClr val="AACCFF"/>
                 </a:solidFill>
               </a:rPr>
-              <a:t>Internet Access Architecture for Intranet Staff</a:t>
+              <a:t>Internet Access Architecture for Intranet Staff (No ALB)</a:t>
             </a:r>
           </a:p>
         </p:txBody>
@@ -3211,8 +3211,8 @@
         </p:nvSpPr>
         <p:spPr>
           <a:xfrm>
-            <a:off x="914400" y="5303520"/>
-            <a:ext cx="10360152" cy="548640"/>
+            <a:off x="914400" y="5394960"/>
+            <a:ext cx="10360152" cy="457200"/>
           </a:xfrm>
           <a:prstGeom prst="rect">
             <a:avLst/>
@@ -3232,7 +3232,7 @@
                   <a:srgbClr val="88AACC"/>
                 </a:solidFill>
               </a:rPr>
-              <a:t>UAT Environment  |  ap-southeast-1</a:t>
+              <a:t>UAT  |  ap-southeast-1  |  CloudFront → EC2 (direct)</a:t>
             </a:r>
           </a:p>
         </p:txBody>
@@ -3306,8 +3306,8 @@
         </p:nvSpPr>
         <p:spPr>
           <a:xfrm>
-            <a:off x="182880" y="45720"/>
-            <a:ext cx="11795760" cy="594360"/>
+            <a:off x="182880" y="73152"/>
+            <a:ext cx="11795760" cy="548640"/>
           </a:xfrm>
           <a:prstGeom prst="rect">
             <a:avLst/>
@@ -3327,7 +3327,7 @@
                   <a:srgbClr val="FFFFFF"/>
                 </a:solidFill>
               </a:rPr>
-              <a:t>Architecture Overview — Mailpit Internet Access</a:t>
+              <a:t>Architecture Flow — CloudFront Direct to EC2 (no ALB)</a:t>
             </a:r>
           </a:p>
         </p:txBody>
@@ -3341,7 +3341,7 @@
         <p:spPr>
           <a:xfrm>
             <a:off x="137160" y="914400"/>
-            <a:ext cx="2011680" cy="320040"/>
+            <a:ext cx="2286000" cy="292608"/>
           </a:xfrm>
           <a:prstGeom prst="rect">
             <a:avLst/>
@@ -3374,8 +3374,8 @@
         </p:nvSpPr>
         <p:spPr>
           <a:xfrm>
-            <a:off x="6583680" y="914400"/>
-            <a:ext cx="2286000" cy="320040"/>
+            <a:off x="8503920" y="914400"/>
+            <a:ext cx="3474720" cy="292608"/>
           </a:xfrm>
           <a:prstGeom prst="rect">
             <a:avLst/>
@@ -3395,7 +3395,7 @@
                   <a:srgbClr val="248814"/>
                 </a:solidFill>
               </a:rPr>
-              <a:t>INTRANET ZONE</a:t>
+              <a:t>INTRANET ZONE / APP TIER</a:t>
             </a:r>
           </a:p>
         </p:txBody>
@@ -3408,8 +3408,8 @@
         </p:nvSpPr>
         <p:spPr>
           <a:xfrm>
-            <a:off x="182880" y="1371600"/>
-            <a:ext cx="1645920" cy="1005840"/>
+            <a:off x="137160" y="1280160"/>
+            <a:ext cx="1737360" cy="960120"/>
           </a:xfrm>
           <a:prstGeom prst="rect">
             <a:avLst/>
@@ -3453,8 +3453,8 @@
         </p:nvSpPr>
         <p:spPr>
           <a:xfrm>
-            <a:off x="228600" y="1417320"/>
-            <a:ext cx="1554480" cy="914400"/>
+            <a:off x="182880" y="1353312"/>
+            <a:ext cx="1645919" cy="822960"/>
           </a:xfrm>
           <a:prstGeom prst="rect">
             <a:avLst/>
@@ -3474,8 +3474,8 @@
                   <a:srgbClr val="222222"/>
                 </a:solidFill>
               </a:rPr>
-              <a:t>(1) Intranet Staff
-(Internet Notebook)</a:t>
+              <a:t>(1) GSIB / WOG
+Notebook</a:t>
             </a:r>
           </a:p>
         </p:txBody>
@@ -3488,8 +3488,8 @@
         </p:nvSpPr>
         <p:spPr>
           <a:xfrm>
-            <a:off x="2103120" y="1371600"/>
-            <a:ext cx="1645920" cy="1005840"/>
+            <a:off x="2057400" y="1280160"/>
+            <a:ext cx="1737360" cy="960120"/>
           </a:xfrm>
           <a:prstGeom prst="rect">
             <a:avLst/>
@@ -3533,8 +3533,8 @@
         </p:nvSpPr>
         <p:spPr>
           <a:xfrm>
-            <a:off x="2148839" y="1417320"/>
-            <a:ext cx="1554480" cy="914400"/>
+            <a:off x="2103120" y="1353312"/>
+            <a:ext cx="1645919" cy="822960"/>
           </a:xfrm>
           <a:prstGeom prst="rect">
             <a:avLst/>
@@ -3568,8 +3568,8 @@
         </p:nvSpPr>
         <p:spPr>
           <a:xfrm>
-            <a:off x="3840480" y="1371600"/>
-            <a:ext cx="1645920" cy="1005840"/>
+            <a:off x="3977639" y="1280160"/>
+            <a:ext cx="1737360" cy="960120"/>
           </a:xfrm>
           <a:prstGeom prst="rect">
             <a:avLst/>
@@ -3613,8 +3613,8 @@
         </p:nvSpPr>
         <p:spPr>
           <a:xfrm>
-            <a:off x="3886200" y="1417320"/>
-            <a:ext cx="1554480" cy="914400"/>
+            <a:off x="4023359" y="1353312"/>
+            <a:ext cx="1645919" cy="822960"/>
           </a:xfrm>
           <a:prstGeom prst="rect">
             <a:avLst/>
@@ -3635,7 +3635,7 @@
                 </a:solidFill>
               </a:rPr>
               <a:t>(3) Route 53
-DNS Resolution</a:t>
+DNS</a:t>
             </a:r>
           </a:p>
         </p:txBody>
@@ -3648,8 +3648,8 @@
         </p:nvSpPr>
         <p:spPr>
           <a:xfrm>
-            <a:off x="5760720" y="1371600"/>
-            <a:ext cx="1645920" cy="1005840"/>
+            <a:off x="5897880" y="1280160"/>
+            <a:ext cx="1737360" cy="960120"/>
           </a:xfrm>
           <a:prstGeom prst="rect">
             <a:avLst/>
@@ -3693,8 +3693,8 @@
         </p:nvSpPr>
         <p:spPr>
           <a:xfrm>
-            <a:off x="5806440" y="1417320"/>
-            <a:ext cx="1554480" cy="914400"/>
+            <a:off x="5943600" y="1353312"/>
+            <a:ext cx="1645919" cy="822960"/>
           </a:xfrm>
           <a:prstGeom prst="rect">
             <a:avLst/>
@@ -3715,7 +3715,6 @@
                 </a:solidFill>
               </a:rPr>
               <a:t>(4) CloudFront
-Distribution
 (Mailpit CDN)</a:t>
             </a:r>
           </a:p>
@@ -3729,8 +3728,8 @@
         </p:nvSpPr>
         <p:spPr>
           <a:xfrm>
-            <a:off x="7680960" y="1371600"/>
-            <a:ext cx="1645920" cy="1005840"/>
+            <a:off x="7818120" y="1280160"/>
+            <a:ext cx="1737360" cy="960120"/>
           </a:xfrm>
           <a:prstGeom prst="rect">
             <a:avLst/>
@@ -3774,8 +3773,8 @@
         </p:nvSpPr>
         <p:spPr>
           <a:xfrm>
-            <a:off x="7726680" y="1417320"/>
-            <a:ext cx="1554480" cy="914400"/>
+            <a:off x="7863840" y="1353312"/>
+            <a:ext cx="1645919" cy="822960"/>
           </a:xfrm>
           <a:prstGeom prst="rect">
             <a:avLst/>
@@ -3796,8 +3795,7 @@
                 </a:solidFill>
               </a:rPr>
               <a:t>(5) AWS WAF
-Intranet IP
-Allowlist</a:t>
+(IP Allowlist)</a:t>
             </a:r>
           </a:p>
         </p:txBody>
@@ -3810,18 +3808,18 @@
         </p:nvSpPr>
         <p:spPr>
           <a:xfrm>
-            <a:off x="9601200" y="1371600"/>
-            <a:ext cx="2286000" cy="1005840"/>
+            <a:off x="9738360" y="1280160"/>
+            <a:ext cx="2286000" cy="960120"/>
           </a:xfrm>
           <a:prstGeom prst="rect">
             <a:avLst/>
           </a:prstGeom>
           <a:solidFill>
-            <a:srgbClr val="EAD8FF"/>
+            <a:srgbClr val="FFE5CC"/>
           </a:solidFill>
           <a:ln w="19050">
             <a:solidFill>
-              <a:srgbClr val="693CC5"/>
+              <a:srgbClr val="D86613"/>
             </a:solidFill>
           </a:ln>
         </p:spPr>
@@ -3855,8 +3853,8 @@
         </p:nvSpPr>
         <p:spPr>
           <a:xfrm>
-            <a:off x="9646920" y="1417320"/>
-            <a:ext cx="2194560" cy="914400"/>
+            <a:off x="9784080" y="1353312"/>
+            <a:ext cx="2194560" cy="822960"/>
           </a:xfrm>
           <a:prstGeom prst="rect">
             <a:avLst/>
@@ -3876,9 +3874,9 @@
                   <a:srgbClr val="222222"/>
                 </a:solidFill>
               </a:rPr>
-              <a:t>(6) Mailpit ALB
-(App Tier -
-Intranet)</a:t>
+              <a:t>(6) Mailpit EC2
+(EIP:8025)
+Email Capture</a:t>
             </a:r>
           </a:p>
         </p:txBody>
@@ -3891,7 +3889,7 @@
         </p:nvSpPr>
         <p:spPr>
           <a:xfrm>
-            <a:off x="1920240" y="1737360"/>
+            <a:off x="1892807" y="1645920"/>
             <a:ext cx="182880" cy="274320"/>
           </a:xfrm>
           <a:prstGeom prst="rect">
@@ -3925,7 +3923,7 @@
         </p:nvSpPr>
         <p:spPr>
           <a:xfrm>
-            <a:off x="3749039" y="1737360"/>
+            <a:off x="3813048" y="1645920"/>
             <a:ext cx="182880" cy="274320"/>
           </a:xfrm>
           <a:prstGeom prst="rect">
@@ -3959,7 +3957,7 @@
         </p:nvSpPr>
         <p:spPr>
           <a:xfrm>
-            <a:off x="5577840" y="1737360"/>
+            <a:off x="5733288" y="1645920"/>
             <a:ext cx="182880" cy="274320"/>
           </a:xfrm>
           <a:prstGeom prst="rect">
@@ -3993,7 +3991,7 @@
         </p:nvSpPr>
         <p:spPr>
           <a:xfrm>
-            <a:off x="7498079" y="1737360"/>
+            <a:off x="7653527" y="1645920"/>
             <a:ext cx="182880" cy="274320"/>
           </a:xfrm>
           <a:prstGeom prst="rect">
@@ -4027,7 +4025,7 @@
         </p:nvSpPr>
         <p:spPr>
           <a:xfrm>
-            <a:off x="9418320" y="1737360"/>
+            <a:off x="9573768" y="1645920"/>
             <a:ext cx="182880" cy="274320"/>
           </a:xfrm>
           <a:prstGeom prst="rect">
@@ -4061,8 +4059,8 @@
         </p:nvSpPr>
         <p:spPr>
           <a:xfrm>
-            <a:off x="5303520" y="2514600"/>
-            <a:ext cx="2743200" cy="822960"/>
+            <a:off x="5577840" y="2468880"/>
+            <a:ext cx="4389120" cy="777240"/>
           </a:xfrm>
           <a:prstGeom prst="rect">
             <a:avLst/>
@@ -4106,8 +4104,8 @@
         </p:nvSpPr>
         <p:spPr>
           <a:xfrm>
-            <a:off x="5349240" y="2560320"/>
-            <a:ext cx="2651760" cy="731520"/>
+            <a:off x="5623560" y="2514600"/>
+            <a:ext cx="4297680" cy="713232"/>
           </a:xfrm>
           <a:prstGeom prst="rect">
             <a:avLst/>
@@ -4127,9 +4125,9 @@
                   <a:srgbClr val="554400"/>
                 </a:solidFill>
               </a:rPr>
-              <a:t>🔓 Firewall Rule
-Allow HTTPS (443) from CloudFront IP ranges
-to Mailpit ALB Security Group</a:t>
+              <a:t>Firewall Rule: Allow HTTPS (443) from CloudFront
+managed prefix list directly to EC2 SG port 8025.
+No ALB required — CloudFront custom origin = EIP:8025</a:t>
             </a:r>
           </a:p>
         </p:txBody>
@@ -4142,18 +4140,18 @@
         </p:nvSpPr>
         <p:spPr>
           <a:xfrm>
-            <a:off x="9601200" y="3520440"/>
-            <a:ext cx="2286000" cy="914400"/>
+            <a:off x="137160" y="2468880"/>
+            <a:ext cx="5303520" cy="777240"/>
           </a:xfrm>
           <a:prstGeom prst="rect">
             <a:avLst/>
           </a:prstGeom>
           <a:solidFill>
-            <a:srgbClr val="FFE5CC"/>
+            <a:srgbClr val="F0FFF0"/>
           </a:solidFill>
           <a:ln w="19050">
             <a:solidFill>
-              <a:srgbClr val="D86613"/>
+              <a:srgbClr val="248814"/>
             </a:solidFill>
           </a:ln>
         </p:spPr>
@@ -4187,8 +4185,8 @@
         </p:nvSpPr>
         <p:spPr>
           <a:xfrm>
-            <a:off x="9646920" y="3566160"/>
-            <a:ext cx="2194560" cy="822960"/>
+            <a:off x="182880" y="2514600"/>
+            <a:ext cx="5120640" cy="713232"/>
           </a:xfrm>
           <a:prstGeom prst="rect">
             <a:avLst/>
@@ -4201,50 +4199,16 @@
           </a:bodyPr>
           <a:lstStyle/>
           <a:p>
-            <a:pPr algn="ctr"/>
-            <a:r>
-              <a:rPr sz="950" b="0">
-                <a:solidFill>
-                  <a:srgbClr val="331100"/>
+            <a:pPr algn="l"/>
+            <a:r>
+              <a:rPr sz="900" b="0">
+                <a:solidFill>
+                  <a:srgbClr val="114411"/>
                 </a:solidFill>
               </a:rPr>
-              <a:t>(7) Mailpit EC2
-(Email Capture)
-Port 8025</a:t>
-            </a:r>
-          </a:p>
-        </p:txBody>
-      </p:sp>
-      <p:sp>
-        <p:nvSpPr>
-          <p:cNvPr id="27" name="TextBox 26"/>
-          <p:cNvSpPr txBox="1"/>
-          <p:nvPr/>
-        </p:nvSpPr>
-        <p:spPr>
-          <a:xfrm>
-            <a:off x="10241280" y="2423160"/>
-            <a:ext cx="1005840" cy="228600"/>
-          </a:xfrm>
-          <a:prstGeom prst="rect">
-            <a:avLst/>
-          </a:prstGeom>
-          <a:noFill/>
-        </p:spPr>
-        <p:txBody>
-          <a:bodyPr wrap="square">
-            <a:spAutoFit/>
-          </a:bodyPr>
-          <a:lstStyle/>
-          <a:p>
-            <a:pPr algn="l"/>
-            <a:r>
-              <a:rPr sz="900" b="1">
-                <a:solidFill>
-                  <a:srgbClr val="D86613"/>
-                </a:solidFill>
-              </a:rPr>
-              <a:t>↓  Port 8025</a:t>
+              <a:t>EC2 Security Group:
+ • Port 8025 (web UI) — allow from CloudFront prefix list only
+ • Port 1025 (SMTP)   — allow from internal VPC CIDR (app servers)</a:t>
             </a:r>
           </a:p>
         </p:txBody>
@@ -4318,8 +4282,8 @@
         </p:nvSpPr>
         <p:spPr>
           <a:xfrm>
-            <a:off x="182880" y="45720"/>
-            <a:ext cx="11795760" cy="594360"/>
+            <a:off x="182880" y="73152"/>
+            <a:ext cx="11795760" cy="548640"/>
           </a:xfrm>
           <a:prstGeom prst="rect">
             <a:avLst/>
@@ -4339,7 +4303,7 @@
                   <a:srgbClr val="FFFFFF"/>
                 </a:solidFill>
               </a:rPr>
-              <a:t>New Architecture Components</a:t>
+              <a:t>New Components (v6 — No ALB)</a:t>
             </a:r>
           </a:p>
         </p:txBody>
@@ -4352,8 +4316,8 @@
         </p:nvSpPr>
         <p:spPr>
           <a:xfrm>
-            <a:off x="182880" y="822960"/>
-            <a:ext cx="2103120" cy="731519"/>
+            <a:off x="182880" y="804672"/>
+            <a:ext cx="2103120" cy="868680"/>
           </a:xfrm>
           <a:prstGeom prst="rect">
             <a:avLst/>
@@ -4397,8 +4361,8 @@
         </p:nvSpPr>
         <p:spPr>
           <a:xfrm>
-            <a:off x="228600" y="914400"/>
-            <a:ext cx="2011680" cy="548640"/>
+            <a:off x="228600" y="941832"/>
+            <a:ext cx="2011680" cy="594360"/>
           </a:xfrm>
           <a:prstGeom prst="rect">
             <a:avLst/>
@@ -4431,8 +4395,8 @@
         </p:nvSpPr>
         <p:spPr>
           <a:xfrm>
-            <a:off x="2423160" y="914400"/>
-            <a:ext cx="9555480" cy="548640"/>
+            <a:off x="2423160" y="896112"/>
+            <a:ext cx="9555480" cy="731520"/>
           </a:xfrm>
           <a:prstGeom prst="rect">
             <a:avLst/>
@@ -4447,13 +4411,12 @@
           <a:p>
             <a:pPr algn="l"/>
             <a:r>
-              <a:rPr sz="1050" b="0">
+              <a:rPr sz="1000" b="0">
                 <a:solidFill>
                   <a:srgbClr val="222222"/>
                 </a:solidFill>
               </a:rPr>
-              <a:t>Public DNS domain (e.g. mailpit.example.gov.sg) registered under the
-Whole-of-Government domain, accessible from the internet.</a:t>
+              <a:t>Public internet-facing DNS name (e.g. mailpit.example.gov.sg) under the Whole-of-Government domain. Registered in Route 53 and pointed at the CloudFront distribution as an A alias record.</a:t>
             </a:r>
           </a:p>
         </p:txBody>
@@ -4466,8 +4429,8 @@
         </p:nvSpPr>
         <p:spPr>
           <a:xfrm>
-            <a:off x="182880" y="1600200"/>
-            <a:ext cx="2103120" cy="731519"/>
+            <a:off x="182880" y="1737360"/>
+            <a:ext cx="2103120" cy="868680"/>
           </a:xfrm>
           <a:prstGeom prst="rect">
             <a:avLst/>
@@ -4511,8 +4474,8 @@
         </p:nvSpPr>
         <p:spPr>
           <a:xfrm>
-            <a:off x="228600" y="1691640"/>
-            <a:ext cx="2011680" cy="548640"/>
+            <a:off x="228600" y="1874519"/>
+            <a:ext cx="2011680" cy="594360"/>
           </a:xfrm>
           <a:prstGeom prst="rect">
             <a:avLst/>
@@ -4545,8 +4508,8 @@
         </p:nvSpPr>
         <p:spPr>
           <a:xfrm>
-            <a:off x="2423160" y="1691640"/>
-            <a:ext cx="9555480" cy="548640"/>
+            <a:off x="2423160" y="1828800"/>
+            <a:ext cx="9555480" cy="731520"/>
           </a:xfrm>
           <a:prstGeom prst="rect">
             <a:avLst/>
@@ -4561,13 +4524,12 @@
           <a:p>
             <a:pPr algn="l"/>
             <a:r>
-              <a:rPr sz="1050" b="0">
+              <a:rPr sz="1000" b="0">
                 <a:solidFill>
                   <a:srgbClr val="222222"/>
                 </a:solidFill>
               </a:rPr>
-              <a:t>AWS Route 53 hosted zone for the WOG domain, pointing to the
-CloudFront distribution as the origin.</a:t>
+              <a:t>AWS hosted zone for the WOG domain. Resolves the domain to the CloudFront distribution's domain name so that browser requests reach CloudFront first.</a:t>
             </a:r>
           </a:p>
         </p:txBody>
@@ -4580,8 +4542,8 @@
         </p:nvSpPr>
         <p:spPr>
           <a:xfrm>
-            <a:off x="182880" y="2377440"/>
-            <a:ext cx="2103120" cy="731519"/>
+            <a:off x="182880" y="2670048"/>
+            <a:ext cx="2103120" cy="868680"/>
           </a:xfrm>
           <a:prstGeom prst="rect">
             <a:avLst/>
@@ -4625,8 +4587,8 @@
         </p:nvSpPr>
         <p:spPr>
           <a:xfrm>
-            <a:off x="228600" y="2468880"/>
-            <a:ext cx="2011680" cy="548640"/>
+            <a:off x="228600" y="2807208"/>
+            <a:ext cx="2011680" cy="594360"/>
           </a:xfrm>
           <a:prstGeom prst="rect">
             <a:avLst/>
@@ -4659,8 +4621,8 @@
         </p:nvSpPr>
         <p:spPr>
           <a:xfrm>
-            <a:off x="2423160" y="2468880"/>
-            <a:ext cx="9555480" cy="548640"/>
+            <a:off x="2423160" y="2761488"/>
+            <a:ext cx="9555480" cy="731520"/>
           </a:xfrm>
           <a:prstGeom prst="rect">
             <a:avLst/>
@@ -4675,13 +4637,12 @@
           <a:p>
             <a:pPr algn="l"/>
             <a:r>
-              <a:rPr sz="1050" b="0">
+              <a:rPr sz="1000" b="0">
                 <a:solidFill>
                   <a:srgbClr val="222222"/>
                 </a:solidFill>
               </a:rPr>
-              <a:t>Terminates HTTPS from internet users. Acts as the entry point for
-Mailpit, forwarding requests to the Mailpit ALB in the Intranet App Tier.</a:t>
+              <a:t>Terminates HTTPS from WOG notebook users. Custom origin = Mailpit Elastic IP on port 8025 (HTTP). CloudFront handles TLS, WAF enforcement, and caching (caching should be DISABLED for Mailpit UI).</a:t>
             </a:r>
           </a:p>
         </p:txBody>
@@ -4694,8 +4655,8 @@
         </p:nvSpPr>
         <p:spPr>
           <a:xfrm>
-            <a:off x="182880" y="3154679"/>
-            <a:ext cx="2103120" cy="731519"/>
+            <a:off x="182880" y="3602736"/>
+            <a:ext cx="2103120" cy="868680"/>
           </a:xfrm>
           <a:prstGeom prst="rect">
             <a:avLst/>
@@ -4739,8 +4700,8 @@
         </p:nvSpPr>
         <p:spPr>
           <a:xfrm>
-            <a:off x="228600" y="3246120"/>
-            <a:ext cx="2011680" cy="548640"/>
+            <a:off x="228600" y="3739896"/>
+            <a:ext cx="2011680" cy="594360"/>
           </a:xfrm>
           <a:prstGeom prst="rect">
             <a:avLst/>
@@ -4773,8 +4734,8 @@
         </p:nvSpPr>
         <p:spPr>
           <a:xfrm>
-            <a:off x="2423160" y="3246120"/>
-            <a:ext cx="9555480" cy="548640"/>
+            <a:off x="2423160" y="3694176"/>
+            <a:ext cx="9555480" cy="731520"/>
           </a:xfrm>
           <a:prstGeom prst="rect">
             <a:avLst/>
@@ -4789,13 +4750,12 @@
           <a:p>
             <a:pPr algn="l"/>
             <a:r>
-              <a:rPr sz="1050" b="0">
+              <a:rPr sz="1000" b="0">
                 <a:solidFill>
                   <a:srgbClr val="222222"/>
                 </a:solidFill>
               </a:rPr>
-              <a:t>Attached to CloudFront. Restricts access to the specific public egress
-IP ranges used by intranet staff internet machines (see Slide 4 for IP details).</a:t>
+              <a:t>Attached to the CloudFront distribution. Default action = BLOCK. An ALLOW rule matches an IP set containing the WOG/GSIB internet gateway egress CIDRs — only government staff reach Mailpit.</a:t>
             </a:r>
           </a:p>
         </p:txBody>
@@ -4808,18 +4768,18 @@
         </p:nvSpPr>
         <p:spPr>
           <a:xfrm>
-            <a:off x="182880" y="3931920"/>
-            <a:ext cx="2103120" cy="731519"/>
+            <a:off x="182880" y="4535424"/>
+            <a:ext cx="2103120" cy="868680"/>
           </a:xfrm>
           <a:prstGeom prst="rect">
             <a:avLst/>
           </a:prstGeom>
           <a:solidFill>
-            <a:srgbClr val="EAD8FF"/>
+            <a:srgbClr val="E8FFE8"/>
           </a:solidFill>
           <a:ln w="19050">
             <a:solidFill>
-              <a:srgbClr val="693CC5"/>
+              <a:srgbClr val="248814"/>
             </a:solidFill>
           </a:ln>
         </p:spPr>
@@ -4853,8 +4813,8 @@
         </p:nvSpPr>
         <p:spPr>
           <a:xfrm>
-            <a:off x="228600" y="4023359"/>
-            <a:ext cx="2011680" cy="548640"/>
+            <a:off x="228600" y="4672584"/>
+            <a:ext cx="2011680" cy="594360"/>
           </a:xfrm>
           <a:prstGeom prst="rect">
             <a:avLst/>
@@ -4874,7 +4834,7 @@
                   <a:srgbClr val="111155"/>
                 </a:solidFill>
               </a:rPr>
-              <a:t>Mailpit ALB</a:t>
+              <a:t>EC2 Security Group</a:t>
             </a:r>
           </a:p>
         </p:txBody>
@@ -4887,8 +4847,8 @@
         </p:nvSpPr>
         <p:spPr>
           <a:xfrm>
-            <a:off x="2423160" y="4023359"/>
-            <a:ext cx="9555480" cy="548640"/>
+            <a:off x="2423160" y="4626864"/>
+            <a:ext cx="9555480" cy="731520"/>
           </a:xfrm>
           <a:prstGeom prst="rect">
             <a:avLst/>
@@ -4903,13 +4863,12 @@
           <a:p>
             <a:pPr algn="l"/>
             <a:r>
-              <a:rPr sz="1050" b="0">
+              <a:rPr sz="1000" b="0">
                 <a:solidFill>
                   <a:srgbClr val="222222"/>
                 </a:solidFill>
               </a:rPr>
-              <a:t>Application Load Balancer added to the App Tier (Intranet Compartment).
-CloudFront forwards HTTPS (443) here; ALB routes to Mailpit EC2 on port 8025.</a:t>
+              <a:t>Port 8025 inbound: SourcePrefixListId = CloudFront origin-facing managed prefix list (com.amazonaws.global.cloudfront.origin-facing). This ensures ONLY CloudFront can hit the UI — no direct access bypassing WAF. Port 1025: internal CIDR for app servers sending test mail.</a:t>
             </a:r>
           </a:p>
         </p:txBody>
@@ -4922,8 +4881,8 @@
         </p:nvSpPr>
         <p:spPr>
           <a:xfrm>
-            <a:off x="182880" y="4709160"/>
-            <a:ext cx="2103120" cy="731519"/>
+            <a:off x="182880" y="5468112"/>
+            <a:ext cx="2103120" cy="868680"/>
           </a:xfrm>
           <a:prstGeom prst="rect">
             <a:avLst/>
@@ -4967,8 +4926,8 @@
         </p:nvSpPr>
         <p:spPr>
           <a:xfrm>
-            <a:off x="228600" y="4800600"/>
-            <a:ext cx="2011680" cy="548640"/>
+            <a:off x="228600" y="5605272"/>
+            <a:ext cx="2011680" cy="594360"/>
           </a:xfrm>
           <a:prstGeom prst="rect">
             <a:avLst/>
@@ -5001,8 +4960,8 @@
         </p:nvSpPr>
         <p:spPr>
           <a:xfrm>
-            <a:off x="2423160" y="4800600"/>
-            <a:ext cx="9555480" cy="548640"/>
+            <a:off x="2423160" y="5559551"/>
+            <a:ext cx="9555480" cy="731520"/>
           </a:xfrm>
           <a:prstGeom prst="rect">
             <a:avLst/>
@@ -5017,13 +4976,12 @@
           <a:p>
             <a:pPr algn="l"/>
             <a:r>
-              <a:rPr sz="1050" b="0">
+              <a:rPr sz="1000" b="0">
                 <a:solidFill>
                   <a:srgbClr val="222222"/>
                 </a:solidFill>
               </a:rPr>
-              <a:t>New firewall rule: Allow inbound HTTPS (TCP 443) from CloudFront managed
-prefix list (com.amazonaws.global.cloudfront.origin-facing) to Mailpit ALB SG.</a:t>
+              <a:t>Allow TCP 443 inbound from CloudFront to the EC2 Elastic IP on port 8025. Because CloudFront uses HTTP to the origin (within AWS), the relevant rule is allowing CloudFront prefix list → EC2 SG port 8025.</a:t>
             </a:r>
           </a:p>
         </p:txBody>
@@ -5097,8 +5055,8 @@
         </p:nvSpPr>
         <p:spPr>
           <a:xfrm>
-            <a:off x="182880" y="45720"/>
-            <a:ext cx="11795760" cy="594360"/>
+            <a:off x="182880" y="73152"/>
+            <a:ext cx="11795760" cy="548640"/>
           </a:xfrm>
           <a:prstGeom prst="rect">
             <a:avLst/>
@@ -5118,7 +5076,7 @@
                   <a:srgbClr val="FFFFFF"/>
                 </a:solidFill>
               </a:rPr>
-              <a:t>Intranet IP Allowlist — WAF Configuration</a:t>
+              <a:t>Intranet IP Allowlist — AWS WAF Configuration</a:t>
             </a:r>
           </a:p>
         </p:txBody>
@@ -5132,7 +5090,7 @@
         <p:spPr>
           <a:xfrm>
             <a:off x="274320" y="822960"/>
-            <a:ext cx="11612880" cy="457200"/>
+            <a:ext cx="11612880" cy="365760"/>
           </a:xfrm>
           <a:prstGeom prst="rect">
             <a:avLst/>
@@ -5152,7 +5110,7 @@
                   <a:srgbClr val="1F497D"/>
                 </a:solidFill>
               </a:rPr>
-              <a:t>Q: If the intranet has a range of IPs, is it possible to list specific IPs used by intranet users?</a:t>
+              <a:t>Q: Can we list specific IP ranges used by intranet users?</a:t>
             </a:r>
           </a:p>
         </p:txBody>
@@ -5165,8 +5123,8 @@
         </p:nvSpPr>
         <p:spPr>
           <a:xfrm>
-            <a:off x="274320" y="1325880"/>
-            <a:ext cx="11612880" cy="365760"/>
+            <a:off x="274320" y="1234440"/>
+            <a:ext cx="11612880" cy="347472"/>
           </a:xfrm>
           <a:prstGeom prst="rect">
             <a:avLst/>
@@ -5186,7 +5144,7 @@
                   <a:srgbClr val="248814"/>
                 </a:solidFill>
               </a:rPr>
-              <a:t>✅  Yes — and it is the recommended approach.</a:t>
+              <a:t>Yes — this is the recommended approach.</a:t>
             </a:r>
           </a:p>
         </p:txBody>
@@ -5199,8 +5157,8 @@
         </p:nvSpPr>
         <p:spPr>
           <a:xfrm>
-            <a:off x="274320" y="1737360"/>
-            <a:ext cx="11612880" cy="685800"/>
+            <a:off x="274320" y="1627632"/>
+            <a:ext cx="11612880" cy="594360"/>
           </a:xfrm>
           <a:prstGeom prst="rect">
             <a:avLst/>
@@ -5220,7 +5178,7 @@
                   <a:srgbClr val="222222"/>
                 </a:solidFill>
               </a:rPr>
-              <a:t>When intranet staff browse the internet from their GSIB/WOG notebooks, their traffic exits through the government's central internet gateway (SGWAN / GovTech-managed proxy). This means their internet source IPs are the public egress IPs of that gateway — not individual device IPs.</a:t>
+              <a:t>Intranet staff on GSIB/WOG notebooks browse the internet through the government's central internet gateway (SGWAN). Their traffic appears at CloudFront with the public egress IPs of that gateway, not individual device IPs. Add those gateway CIDRs to the WAF IP set.</a:t>
             </a:r>
           </a:p>
         </p:txBody>
@@ -5233,8 +5191,8 @@
         </p:nvSpPr>
         <p:spPr>
           <a:xfrm>
-            <a:off x="274320" y="2514600"/>
-            <a:ext cx="11612880" cy="320040"/>
+            <a:off x="274320" y="2331720"/>
+            <a:ext cx="11612880" cy="292608"/>
           </a:xfrm>
           <a:prstGeom prst="rect">
             <a:avLst/>
@@ -5254,7 +5212,7 @@
                   <a:srgbClr val="1F497D"/>
                 </a:solidFill>
               </a:rPr>
-              <a:t>How to configure the AWS WAF IP Allowlist:</a:t>
+              <a:t>Configuration steps:</a:t>
             </a:r>
           </a:p>
         </p:txBody>
@@ -5267,8 +5225,8 @@
         </p:nvSpPr>
         <p:spPr>
           <a:xfrm>
-            <a:off x="274320" y="2880360"/>
-            <a:ext cx="1188720" cy="685800"/>
+            <a:off x="274320" y="2697480"/>
+            <a:ext cx="2286000" cy="685800"/>
           </a:xfrm>
           <a:prstGeom prst="rect">
             <a:avLst/>
@@ -5312,8 +5270,8 @@
         </p:nvSpPr>
         <p:spPr>
           <a:xfrm>
-            <a:off x="320040" y="3017520"/>
-            <a:ext cx="1097280" cy="411480"/>
+            <a:off x="320040" y="2834640"/>
+            <a:ext cx="2194560" cy="438912"/>
           </a:xfrm>
           <a:prstGeom prst="rect">
             <a:avLst/>
@@ -5328,12 +5286,12 @@
           <a:p>
             <a:pPr algn="ctr"/>
             <a:r>
-              <a:rPr sz="1100" b="1">
+              <a:rPr sz="1000" b="1">
                 <a:solidFill>
                   <a:srgbClr val="1F497D"/>
                 </a:solidFill>
               </a:rPr>
-              <a:t>Step 1</a:t>
+              <a:t>Step 1 — Get CIDRs</a:t>
             </a:r>
           </a:p>
         </p:txBody>
@@ -5346,8 +5304,8 @@
         </p:nvSpPr>
         <p:spPr>
           <a:xfrm>
-            <a:off x="1600200" y="2926079"/>
-            <a:ext cx="10241280" cy="640080"/>
+            <a:off x="2697480" y="2770632"/>
+            <a:ext cx="9189720" cy="603504"/>
           </a:xfrm>
           <a:prstGeom prst="rect">
             <a:avLst/>
@@ -5362,12 +5320,12 @@
           <a:p>
             <a:pPr algn="l"/>
             <a:r>
-              <a:rPr sz="1000" b="0">
+              <a:rPr sz="950" b="0">
                 <a:solidFill>
                   <a:srgbClr val="222222"/>
                 </a:solidFill>
               </a:rPr>
-              <a:t>Obtain the egress IP ranges (CIDRs) of the WOG/GSIB internet gateway from your GovTech / ITAS network team. These are the public IPs that government staff's internet traffic appears to come from.</a:t>
+              <a:t>Ask your GovTech / ITAS / SGWAN network team for the public egress IP ranges (CIDRs) of the WOG internet gateway.</a:t>
             </a:r>
           </a:p>
         </p:txBody>
@@ -5380,8 +5338,8 @@
         </p:nvSpPr>
         <p:spPr>
           <a:xfrm>
-            <a:off x="274320" y="3639312"/>
-            <a:ext cx="1188720" cy="685800"/>
+            <a:off x="274320" y="3456432"/>
+            <a:ext cx="2286000" cy="685800"/>
           </a:xfrm>
           <a:prstGeom prst="rect">
             <a:avLst/>
@@ -5425,8 +5383,8 @@
         </p:nvSpPr>
         <p:spPr>
           <a:xfrm>
-            <a:off x="320040" y="3776472"/>
-            <a:ext cx="1097280" cy="411480"/>
+            <a:off x="320040" y="3593592"/>
+            <a:ext cx="2194560" cy="438912"/>
           </a:xfrm>
           <a:prstGeom prst="rect">
             <a:avLst/>
@@ -5441,12 +5399,12 @@
           <a:p>
             <a:pPr algn="ctr"/>
             <a:r>
-              <a:rPr sz="1100" b="1">
+              <a:rPr sz="1000" b="1">
                 <a:solidFill>
                   <a:srgbClr val="1F497D"/>
                 </a:solidFill>
               </a:rPr>
-              <a:t>Step 2</a:t>
+              <a:t>Step 2 — WAF IP Set</a:t>
             </a:r>
           </a:p>
         </p:txBody>
@@ -5459,8 +5417,8 @@
         </p:nvSpPr>
         <p:spPr>
           <a:xfrm>
-            <a:off x="1600200" y="3685032"/>
-            <a:ext cx="10241280" cy="640080"/>
+            <a:off x="2697480" y="3529584"/>
+            <a:ext cx="9189720" cy="603504"/>
           </a:xfrm>
           <a:prstGeom prst="rect">
             <a:avLst/>
@@ -5475,13 +5433,13 @@
           <a:p>
             <a:pPr algn="l"/>
             <a:r>
-              <a:rPr sz="1000" b="0">
+              <a:rPr sz="950" b="0">
                 <a:solidFill>
                   <a:srgbClr val="222222"/>
                 </a:solidFill>
               </a:rPr>
-              <a:t>Create an AWS WAF IP set (IPv4) containing those CIDR blocks in ap-southeast-1. Example:
-    10.x.x.x/24 (replace with actual WOG egress CIDRs from your network team)</a:t>
+              <a:t>Create an AWS WAF IP set (IPv4, scope CLOUDFRONT, us-east-1) with those CIDRs.
+    aws wafv2 create-ip-set --scope CLOUDFRONT --region us-east-1 --name mailpit-intranet-ips --ip-address-version IPV4 --addresses &lt;CIDR1&gt; &lt;CIDR2&gt;</a:t>
             </a:r>
           </a:p>
         </p:txBody>
@@ -5494,8 +5452,8 @@
         </p:nvSpPr>
         <p:spPr>
           <a:xfrm>
-            <a:off x="274320" y="4398264"/>
-            <a:ext cx="1188720" cy="685800"/>
+            <a:off x="274320" y="4215384"/>
+            <a:ext cx="2286000" cy="685800"/>
           </a:xfrm>
           <a:prstGeom prst="rect">
             <a:avLst/>
@@ -5539,8 +5497,8 @@
         </p:nvSpPr>
         <p:spPr>
           <a:xfrm>
-            <a:off x="320040" y="4535424"/>
-            <a:ext cx="1097280" cy="411480"/>
+            <a:off x="320040" y="4352544"/>
+            <a:ext cx="2194560" cy="438912"/>
           </a:xfrm>
           <a:prstGeom prst="rect">
             <a:avLst/>
@@ -5555,12 +5513,12 @@
           <a:p>
             <a:pPr algn="ctr"/>
             <a:r>
-              <a:rPr sz="1100" b="1">
+              <a:rPr sz="1000" b="1">
                 <a:solidFill>
                   <a:srgbClr val="1F497D"/>
                 </a:solidFill>
               </a:rPr>
-              <a:t>Step 3</a:t>
+              <a:t>Step 3 — WAF WebACL</a:t>
             </a:r>
           </a:p>
         </p:txBody>
@@ -5573,8 +5531,8 @@
         </p:nvSpPr>
         <p:spPr>
           <a:xfrm>
-            <a:off x="1600200" y="4443983"/>
-            <a:ext cx="10241280" cy="640080"/>
+            <a:off x="2697480" y="4288536"/>
+            <a:ext cx="9189720" cy="603504"/>
           </a:xfrm>
           <a:prstGeom prst="rect">
             <a:avLst/>
@@ -5589,12 +5547,12 @@
           <a:p>
             <a:pPr algn="l"/>
             <a:r>
-              <a:rPr sz="1000" b="0">
+              <a:rPr sz="950" b="0">
                 <a:solidFill>
                   <a:srgbClr val="222222"/>
                 </a:solidFill>
               </a:rPr>
-              <a:t>Attach a WAF WebACL to the CloudFront distribution with a BLOCK-all default rule and an ALLOW rule that matches the IP set from Step 2.</a:t>
+              <a:t>Create/update a WAF WebACL (CLOUDFRONT scope): default action = BLOCK, add an ALLOW rule matching the IP set above.</a:t>
             </a:r>
           </a:p>
         </p:txBody>
@@ -5607,8 +5565,8 @@
         </p:nvSpPr>
         <p:spPr>
           <a:xfrm>
-            <a:off x="274320" y="5157216"/>
-            <a:ext cx="1188720" cy="685800"/>
+            <a:off x="274320" y="4974336"/>
+            <a:ext cx="2286000" cy="685800"/>
           </a:xfrm>
           <a:prstGeom prst="rect">
             <a:avLst/>
@@ -5652,8 +5610,8 @@
         </p:nvSpPr>
         <p:spPr>
           <a:xfrm>
-            <a:off x="320040" y="5294376"/>
-            <a:ext cx="1097280" cy="411480"/>
+            <a:off x="320040" y="5111496"/>
+            <a:ext cx="2194560" cy="438912"/>
           </a:xfrm>
           <a:prstGeom prst="rect">
             <a:avLst/>
@@ -5668,12 +5626,12 @@
           <a:p>
             <a:pPr algn="ctr"/>
             <a:r>
-              <a:rPr sz="1100" b="1">
+              <a:rPr sz="1000" b="1">
                 <a:solidFill>
                   <a:srgbClr val="1F497D"/>
                 </a:solidFill>
               </a:rPr>
-              <a:t>Step 4</a:t>
+              <a:t>Step 4 — Attach to CloudFront</a:t>
             </a:r>
           </a:p>
         </p:txBody>
@@ -5686,8 +5644,8 @@
         </p:nvSpPr>
         <p:spPr>
           <a:xfrm>
-            <a:off x="1600200" y="5202936"/>
-            <a:ext cx="10241280" cy="640080"/>
+            <a:off x="2697480" y="5047488"/>
+            <a:ext cx="9189720" cy="603504"/>
           </a:xfrm>
           <a:prstGeom prst="rect">
             <a:avLst/>
@@ -5702,26 +5660,139 @@
           <a:p>
             <a:pPr algn="l"/>
             <a:r>
-              <a:rPr sz="1000" b="0">
+              <a:rPr sz="950" b="0">
                 <a:solidFill>
                   <a:srgbClr val="222222"/>
                 </a:solidFill>
               </a:rPr>
-              <a:t>Test access: a GSIB device should reach mailpit.xxx.gov.sg; a non-government IP should receive HTTP 403.</a:t>
-            </a:r>
-          </a:p>
-        </p:txBody>
-      </p:sp>
-      <p:sp>
-        <p:nvSpPr>
-          <p:cNvPr id="20" name="TextBox 19"/>
+              <a:t>Associate the WebACL with the Mailpit CloudFront distribution via the CloudFront console or CLI.</a:t>
+            </a:r>
+          </a:p>
+        </p:txBody>
+      </p:sp>
+      <p:sp>
+        <p:nvSpPr>
+          <p:cNvPr id="20" name="Rectangle 19"/>
+          <p:cNvSpPr/>
+          <p:nvPr/>
+        </p:nvSpPr>
+        <p:spPr>
+          <a:xfrm>
+            <a:off x="274320" y="5733288"/>
+            <a:ext cx="2286000" cy="685800"/>
+          </a:xfrm>
+          <a:prstGeom prst="rect">
+            <a:avLst/>
+          </a:prstGeom>
+          <a:solidFill>
+            <a:srgbClr val="DAE8FC"/>
+          </a:solidFill>
+          <a:ln w="19050">
+            <a:solidFill>
+              <a:srgbClr val="6C8EBF"/>
+            </a:solidFill>
+          </a:ln>
+        </p:spPr>
+        <p:style>
+          <a:lnRef idx="1">
+            <a:schemeClr val="accent1"/>
+          </a:lnRef>
+          <a:fillRef idx="3">
+            <a:schemeClr val="accent1"/>
+          </a:fillRef>
+          <a:effectRef idx="2">
+            <a:schemeClr val="accent1"/>
+          </a:effectRef>
+          <a:fontRef idx="minor">
+            <a:schemeClr val="lt1"/>
+          </a:fontRef>
+        </p:style>
+        <p:txBody>
+          <a:bodyPr rtlCol="0" anchor="ctr"/>
+          <a:lstStyle/>
+          <a:p>
+            <a:pPr algn="ctr"/>
+          </a:p>
+        </p:txBody>
+      </p:sp>
+      <p:sp>
+        <p:nvSpPr>
+          <p:cNvPr id="21" name="TextBox 20"/>
           <p:cNvSpPr txBox="1"/>
           <p:nvPr/>
         </p:nvSpPr>
         <p:spPr>
           <a:xfrm>
-            <a:off x="274320" y="6217920"/>
-            <a:ext cx="11612880" cy="365760"/>
+            <a:off x="320040" y="5870448"/>
+            <a:ext cx="2194560" cy="438912"/>
+          </a:xfrm>
+          <a:prstGeom prst="rect">
+            <a:avLst/>
+          </a:prstGeom>
+          <a:noFill/>
+        </p:spPr>
+        <p:txBody>
+          <a:bodyPr wrap="square">
+            <a:spAutoFit/>
+          </a:bodyPr>
+          <a:lstStyle/>
+          <a:p>
+            <a:pPr algn="ctr"/>
+            <a:r>
+              <a:rPr sz="1000" b="1">
+                <a:solidFill>
+                  <a:srgbClr val="1F497D"/>
+                </a:solidFill>
+              </a:rPr>
+              <a:t>Step 5 — Test</a:t>
+            </a:r>
+          </a:p>
+        </p:txBody>
+      </p:sp>
+      <p:sp>
+        <p:nvSpPr>
+          <p:cNvPr id="22" name="TextBox 21"/>
+          <p:cNvSpPr txBox="1"/>
+          <p:nvPr/>
+        </p:nvSpPr>
+        <p:spPr>
+          <a:xfrm>
+            <a:off x="2697480" y="5806440"/>
+            <a:ext cx="9189720" cy="603504"/>
+          </a:xfrm>
+          <a:prstGeom prst="rect">
+            <a:avLst/>
+          </a:prstGeom>
+          <a:noFill/>
+        </p:spPr>
+        <p:txBody>
+          <a:bodyPr wrap="square">
+            <a:spAutoFit/>
+          </a:bodyPr>
+          <a:lstStyle/>
+          <a:p>
+            <a:pPr algn="l"/>
+            <a:r>
+              <a:rPr sz="950" b="0">
+                <a:solidFill>
+                  <a:srgbClr val="222222"/>
+                </a:solidFill>
+              </a:rPr>
+              <a:t>From a GSIB device: should reach mailpit.xxx.gov.sg.  From a non-WOG IP: should receive HTTP 403 Forbidden.</a:t>
+            </a:r>
+          </a:p>
+        </p:txBody>
+      </p:sp>
+      <p:sp>
+        <p:nvSpPr>
+          <p:cNvPr id="23" name="TextBox 22"/>
+          <p:cNvSpPr txBox="1"/>
+          <p:nvPr/>
+        </p:nvSpPr>
+        <p:spPr>
+          <a:xfrm>
+            <a:off x="274320" y="6400800"/>
+            <a:ext cx="11612880" cy="320040"/>
           </a:xfrm>
           <a:prstGeom prst="rect">
             <a:avLst/>
@@ -5743,7 +5814,7 @@
                   <a:srgbClr val="992200"/>
                 </a:solidFill>
               </a:rPr>
-              <a:t>Note: Do NOT use 0.0.0.0/0 for the WAF IP set — Mailpit captures test emails which may contain sensitive data.</a:t>
+              <a:t>Do NOT use 0.0.0.0/0 — Mailpit captures test emails that may contain sensitive data.</a:t>
             </a:r>
           </a:p>
         </p:txBody>
@@ -5817,8 +5888,8 @@
         </p:nvSpPr>
         <p:spPr>
           <a:xfrm>
-            <a:off x="182880" y="45720"/>
-            <a:ext cx="11795760" cy="594360"/>
+            <a:off x="182880" y="73152"/>
+            <a:ext cx="11795760" cy="548640"/>
           </a:xfrm>
           <a:prstGeom prst="rect">
             <a:avLst/>
@@ -5838,7 +5909,7 @@
                   <a:srgbClr val="FFFFFF"/>
                 </a:solidFill>
               </a:rPr>
-              <a:t>Summary of Architecture Changes</a:t>
+              <a:t>Changes Summary (v6 vs v5)</a:t>
             </a:r>
           </a:p>
         </p:txBody>
@@ -5851,8 +5922,8 @@
         </p:nvSpPr>
         <p:spPr>
           <a:xfrm>
-            <a:off x="274320" y="822960"/>
-            <a:ext cx="11612880" cy="365760"/>
+            <a:off x="274320" y="804672"/>
+            <a:ext cx="11612880" cy="347472"/>
           </a:xfrm>
           <a:prstGeom prst="rect">
             <a:avLst/>
@@ -5867,12 +5938,12 @@
           <a:p>
             <a:pPr algn="l"/>
             <a:r>
-              <a:rPr sz="1300" b="1">
+              <a:rPr sz="1200" b="1">
                 <a:solidFill>
                   <a:srgbClr val="1F497D"/>
                 </a:solidFill>
               </a:rPr>
-              <a:t>What was added to the draw.io diagram (v5):</a:t>
+              <a:t>What changed from v5 → v6:</a:t>
             </a:r>
           </a:p>
         </p:txBody>
@@ -5885,14 +5956,14 @@
         </p:nvSpPr>
         <p:spPr>
           <a:xfrm>
-            <a:off x="274320" y="1280160"/>
-            <a:ext cx="365760" cy="411480"/>
+            <a:off x="274320" y="1234440"/>
+            <a:ext cx="1097280" cy="594360"/>
           </a:xfrm>
           <a:prstGeom prst="rect">
             <a:avLst/>
           </a:prstGeom>
           <a:solidFill>
-            <a:srgbClr val="2382B8"/>
+            <a:srgbClr val="DD344C"/>
           </a:solidFill>
           <a:ln>
             <a:noFill/>
@@ -5928,8 +5999,8 @@
         </p:nvSpPr>
         <p:spPr>
           <a:xfrm>
-            <a:off x="274320" y="1280160"/>
-            <a:ext cx="365760" cy="411480"/>
+            <a:off x="274320" y="1325880"/>
+            <a:ext cx="1097280" cy="411480"/>
           </a:xfrm>
           <a:prstGeom prst="rect">
             <a:avLst/>
@@ -5944,12 +6015,12 @@
           <a:p>
             <a:pPr algn="ctr"/>
             <a:r>
-              <a:rPr sz="1400" b="1">
+              <a:rPr sz="1100" b="1">
                 <a:solidFill>
                   <a:srgbClr val="FFFFFF"/>
                 </a:solidFill>
               </a:rPr>
-              <a:t>✓</a:t>
+              <a:t>REMOVED</a:t>
             </a:r>
           </a:p>
         </p:txBody>
@@ -5962,8 +6033,8 @@
         </p:nvSpPr>
         <p:spPr>
           <a:xfrm>
-            <a:off x="777240" y="1325880"/>
-            <a:ext cx="11064240" cy="411480"/>
+            <a:off x="1508760" y="1325880"/>
+            <a:ext cx="10424160" cy="502920"/>
           </a:xfrm>
           <a:prstGeom prst="rect">
             <a:avLst/>
@@ -5978,12 +6049,12 @@
           <a:p>
             <a:pPr algn="l"/>
             <a:r>
-              <a:rPr sz="1100" b="0">
+              <a:rPr sz="1050" b="0">
                 <a:solidFill>
                   <a:srgbClr val="222222"/>
                 </a:solidFill>
               </a:rPr>
-              <a:t>WOG Domain label — internet-accessible DNS entry point for Mailpit</a:t>
+              <a:t>Mailpit ALB — not needed; CloudFront supports direct EC2 custom origin</a:t>
             </a:r>
           </a:p>
         </p:txBody>
@@ -5996,14 +6067,14 @@
         </p:nvSpPr>
         <p:spPr>
           <a:xfrm>
-            <a:off x="274320" y="1856231"/>
-            <a:ext cx="365760" cy="411480"/>
+            <a:off x="274320" y="1993392"/>
+            <a:ext cx="1097280" cy="594360"/>
           </a:xfrm>
           <a:prstGeom prst="rect">
             <a:avLst/>
           </a:prstGeom>
           <a:solidFill>
-            <a:srgbClr val="2382B8"/>
+            <a:srgbClr val="DD344C"/>
           </a:solidFill>
           <a:ln>
             <a:noFill/>
@@ -6039,8 +6110,8 @@
         </p:nvSpPr>
         <p:spPr>
           <a:xfrm>
-            <a:off x="274320" y="1856231"/>
-            <a:ext cx="365760" cy="411480"/>
+            <a:off x="274320" y="2084832"/>
+            <a:ext cx="1097280" cy="411480"/>
           </a:xfrm>
           <a:prstGeom prst="rect">
             <a:avLst/>
@@ -6055,12 +6126,12 @@
           <a:p>
             <a:pPr algn="ctr"/>
             <a:r>
-              <a:rPr sz="1400" b="1">
+              <a:rPr sz="1100" b="1">
                 <a:solidFill>
                   <a:srgbClr val="FFFFFF"/>
                 </a:solidFill>
               </a:rPr>
-              <a:t>✓</a:t>
+              <a:t>REMOVED</a:t>
             </a:r>
           </a:p>
         </p:txBody>
@@ -6073,8 +6144,8 @@
         </p:nvSpPr>
         <p:spPr>
           <a:xfrm>
-            <a:off x="777240" y="1901951"/>
-            <a:ext cx="11064240" cy="411480"/>
+            <a:off x="1508760" y="2084832"/>
+            <a:ext cx="10424160" cy="502920"/>
           </a:xfrm>
           <a:prstGeom prst="rect">
             <a:avLst/>
@@ -6089,12 +6160,12 @@
           <a:p>
             <a:pPr algn="l"/>
             <a:r>
-              <a:rPr sz="1100" b="0">
+              <a:rPr sz="1050" b="0">
                 <a:solidFill>
                   <a:srgbClr val="222222"/>
                 </a:solidFill>
               </a:rPr>
-              <a:t>Route 53 — DNS resolution for WOG domain, pointing to CloudFront</a:t>
+              <a:t>ALB → EC2 edge and ALB security group rule</a:t>
             </a:r>
           </a:p>
         </p:txBody>
@@ -6107,14 +6178,14 @@
         </p:nvSpPr>
         <p:spPr>
           <a:xfrm>
-            <a:off x="274320" y="2432304"/>
-            <a:ext cx="365760" cy="411480"/>
+            <a:off x="274320" y="2752344"/>
+            <a:ext cx="1097280" cy="594360"/>
           </a:xfrm>
           <a:prstGeom prst="rect">
             <a:avLst/>
           </a:prstGeom>
           <a:solidFill>
-            <a:srgbClr val="2382B8"/>
+            <a:srgbClr val="D86613"/>
           </a:solidFill>
           <a:ln>
             <a:noFill/>
@@ -6150,8 +6221,8 @@
         </p:nvSpPr>
         <p:spPr>
           <a:xfrm>
-            <a:off x="274320" y="2432304"/>
-            <a:ext cx="365760" cy="411480"/>
+            <a:off x="274320" y="2843784"/>
+            <a:ext cx="1097280" cy="411480"/>
           </a:xfrm>
           <a:prstGeom prst="rect">
             <a:avLst/>
@@ -6166,12 +6237,12 @@
           <a:p>
             <a:pPr algn="ctr"/>
             <a:r>
-              <a:rPr sz="1400" b="1">
+              <a:rPr sz="1100" b="1">
                 <a:solidFill>
                   <a:srgbClr val="FFFFFF"/>
                 </a:solidFill>
               </a:rPr>
-              <a:t>✓</a:t>
+              <a:t>UPDATED</a:t>
             </a:r>
           </a:p>
         </p:txBody>
@@ -6184,8 +6255,8 @@
         </p:nvSpPr>
         <p:spPr>
           <a:xfrm>
-            <a:off x="777240" y="2478024"/>
-            <a:ext cx="11064240" cy="411480"/>
+            <a:off x="1508760" y="2843784"/>
+            <a:ext cx="10424160" cy="502920"/>
           </a:xfrm>
           <a:prstGeom prst="rect">
             <a:avLst/>
@@ -6200,12 +6271,12 @@
           <a:p>
             <a:pPr algn="l"/>
             <a:r>
-              <a:rPr sz="1100" b="0">
+              <a:rPr sz="1050" b="0">
                 <a:solidFill>
                   <a:srgbClr val="222222"/>
                 </a:solidFill>
               </a:rPr>
-              <a:t>CloudFront Distribution (Mailpit CDN) — HTTPS termination in Internet Zone</a:t>
+              <a:t>CloudFront now wired directly to Mailpit EC2 Elastic IP (port 8025)</a:t>
             </a:r>
           </a:p>
         </p:txBody>
@@ -6218,14 +6289,14 @@
         </p:nvSpPr>
         <p:spPr>
           <a:xfrm>
-            <a:off x="274320" y="3008376"/>
-            <a:ext cx="365760" cy="411480"/>
+            <a:off x="274320" y="3511296"/>
+            <a:ext cx="1097280" cy="594360"/>
           </a:xfrm>
           <a:prstGeom prst="rect">
             <a:avLst/>
           </a:prstGeom>
           <a:solidFill>
-            <a:srgbClr val="2382B8"/>
+            <a:srgbClr val="D86613"/>
           </a:solidFill>
           <a:ln>
             <a:noFill/>
@@ -6261,8 +6332,8 @@
         </p:nvSpPr>
         <p:spPr>
           <a:xfrm>
-            <a:off x="274320" y="3008376"/>
-            <a:ext cx="365760" cy="411480"/>
+            <a:off x="274320" y="3602736"/>
+            <a:ext cx="1097280" cy="411480"/>
           </a:xfrm>
           <a:prstGeom prst="rect">
             <a:avLst/>
@@ -6277,12 +6348,12 @@
           <a:p>
             <a:pPr algn="ctr"/>
             <a:r>
-              <a:rPr sz="1400" b="1">
+              <a:rPr sz="1100" b="1">
                 <a:solidFill>
                   <a:srgbClr val="FFFFFF"/>
                 </a:solidFill>
               </a:rPr>
-              <a:t>✓</a:t>
+              <a:t>UPDATED</a:t>
             </a:r>
           </a:p>
         </p:txBody>
@@ -6295,8 +6366,8 @@
         </p:nvSpPr>
         <p:spPr>
           <a:xfrm>
-            <a:off x="777240" y="3054096"/>
-            <a:ext cx="11064240" cy="411480"/>
+            <a:off x="1508760" y="3602736"/>
+            <a:ext cx="10424160" cy="502920"/>
           </a:xfrm>
           <a:prstGeom prst="rect">
             <a:avLst/>
@@ -6311,12 +6382,12 @@
           <a:p>
             <a:pPr algn="l"/>
             <a:r>
-              <a:rPr sz="1100" b="0">
+              <a:rPr sz="1050" b="0">
                 <a:solidFill>
                   <a:srgbClr val="222222"/>
                 </a:solidFill>
               </a:rPr>
-              <a:t>AWS WAF (Intranet IP Allowlist) — restricts CloudFront access to WOG egress IPs</a:t>
+              <a:t>CloudFormation template: replaced AllowedCidr for port 8025 with CloudFront managed prefix list (SourcePrefixListId) — prevents bypassing WAF via direct IP access</a:t>
             </a:r>
           </a:p>
         </p:txBody>
@@ -6329,14 +6400,14 @@
         </p:nvSpPr>
         <p:spPr>
           <a:xfrm>
-            <a:off x="274320" y="3584448"/>
-            <a:ext cx="365760" cy="411480"/>
+            <a:off x="274320" y="4270248"/>
+            <a:ext cx="1097280" cy="594360"/>
           </a:xfrm>
           <a:prstGeom prst="rect">
             <a:avLst/>
           </a:prstGeom>
           <a:solidFill>
-            <a:srgbClr val="2382B8"/>
+            <a:srgbClr val="D86613"/>
           </a:solidFill>
           <a:ln>
             <a:noFill/>
@@ -6372,8 +6443,8 @@
         </p:nvSpPr>
         <p:spPr>
           <a:xfrm>
-            <a:off x="274320" y="3584448"/>
-            <a:ext cx="365760" cy="411480"/>
+            <a:off x="274320" y="4361688"/>
+            <a:ext cx="1097280" cy="411480"/>
           </a:xfrm>
           <a:prstGeom prst="rect">
             <a:avLst/>
@@ -6388,12 +6459,12 @@
           <a:p>
             <a:pPr algn="ctr"/>
             <a:r>
-              <a:rPr sz="1400" b="1">
+              <a:rPr sz="1100" b="1">
                 <a:solidFill>
                   <a:srgbClr val="FFFFFF"/>
                 </a:solidFill>
               </a:rPr>
-              <a:t>✓</a:t>
+              <a:t>UPDATED</a:t>
             </a:r>
           </a:p>
         </p:txBody>
@@ -6406,8 +6477,8 @@
         </p:nvSpPr>
         <p:spPr>
           <a:xfrm>
-            <a:off x="777240" y="3630168"/>
-            <a:ext cx="11064240" cy="411480"/>
+            <a:off x="1508760" y="4361688"/>
+            <a:ext cx="10424160" cy="502920"/>
           </a:xfrm>
           <a:prstGeom prst="rect">
             <a:avLst/>
@@ -6422,12 +6493,12 @@
           <a:p>
             <a:pPr algn="l"/>
             <a:r>
-              <a:rPr sz="1100" b="0">
+              <a:rPr sz="1050" b="0">
                 <a:solidFill>
                   <a:srgbClr val="222222"/>
                 </a:solidFill>
               </a:rPr>
-              <a:t>Mailpit ALB — Application Load Balancer in App Tier; CloudFront origin target</a:t>
+              <a:t>Firewall rule note: CloudFront prefix list → EC2:8025 (no ALB hop)</a:t>
             </a:r>
           </a:p>
         </p:txBody>
@@ -6440,14 +6511,14 @@
         </p:nvSpPr>
         <p:spPr>
           <a:xfrm>
-            <a:off x="274320" y="4160520"/>
-            <a:ext cx="365760" cy="411480"/>
+            <a:off x="274320" y="5029200"/>
+            <a:ext cx="1097280" cy="594360"/>
           </a:xfrm>
           <a:prstGeom prst="rect">
             <a:avLst/>
           </a:prstGeom>
           <a:solidFill>
-            <a:srgbClr val="2382B8"/>
+            <a:srgbClr val="248814"/>
           </a:solidFill>
           <a:ln>
             <a:noFill/>
@@ -6483,8 +6554,8 @@
         </p:nvSpPr>
         <p:spPr>
           <a:xfrm>
-            <a:off x="274320" y="4160520"/>
-            <a:ext cx="365760" cy="411480"/>
+            <a:off x="274320" y="5120640"/>
+            <a:ext cx="1097280" cy="411480"/>
           </a:xfrm>
           <a:prstGeom prst="rect">
             <a:avLst/>
@@ -6499,12 +6570,12 @@
           <a:p>
             <a:pPr algn="ctr"/>
             <a:r>
-              <a:rPr sz="1400" b="1">
+              <a:rPr sz="1100" b="1">
                 <a:solidFill>
                   <a:srgbClr val="FFFFFF"/>
                 </a:solidFill>
               </a:rPr>
-              <a:t>✓</a:t>
+              <a:t>ADDED</a:t>
             </a:r>
           </a:p>
         </p:txBody>
@@ -6517,8 +6588,8 @@
         </p:nvSpPr>
         <p:spPr>
           <a:xfrm>
-            <a:off x="777240" y="4206240"/>
-            <a:ext cx="11064240" cy="411480"/>
+            <a:off x="1508760" y="5120640"/>
+            <a:ext cx="10424160" cy="502920"/>
           </a:xfrm>
           <a:prstGeom prst="rect">
             <a:avLst/>
@@ -6533,69 +6604,26 @@
           <a:p>
             <a:pPr algn="l"/>
             <a:r>
-              <a:rPr sz="1100" b="0">
+              <a:rPr sz="1050" b="0">
                 <a:solidFill>
                   <a:srgbClr val="222222"/>
                 </a:solidFill>
               </a:rPr>
-              <a:t>Firewall Rule annotation — HTTPS (443) from CloudFront IP ranges to Mailpit ALB</a:t>
-            </a:r>
-          </a:p>
-        </p:txBody>
-      </p:sp>
-      <p:sp>
-        <p:nvSpPr>
-          <p:cNvPr id="23" name="Rectangle 22"/>
-          <p:cNvSpPr/>
-          <p:nvPr/>
-        </p:nvSpPr>
-        <p:spPr>
-          <a:xfrm>
-            <a:off x="274320" y="4736592"/>
-            <a:ext cx="365760" cy="411480"/>
-          </a:xfrm>
-          <a:prstGeom prst="rect">
-            <a:avLst/>
-          </a:prstGeom>
-          <a:solidFill>
-            <a:srgbClr val="2382B8"/>
-          </a:solidFill>
-          <a:ln>
-            <a:noFill/>
-          </a:ln>
-        </p:spPr>
-        <p:style>
-          <a:lnRef idx="1">
-            <a:schemeClr val="accent1"/>
-          </a:lnRef>
-          <a:fillRef idx="3">
-            <a:schemeClr val="accent1"/>
-          </a:fillRef>
-          <a:effectRef idx="2">
-            <a:schemeClr val="accent1"/>
-          </a:effectRef>
-          <a:fontRef idx="minor">
-            <a:schemeClr val="lt1"/>
-          </a:fontRef>
-        </p:style>
-        <p:txBody>
-          <a:bodyPr rtlCol="0" anchor="ctr"/>
-          <a:lstStyle/>
-          <a:p>
-            <a:pPr algn="ctr"/>
-          </a:p>
-        </p:txBody>
-      </p:sp>
-      <p:sp>
-        <p:nvSpPr>
-          <p:cNvPr id="24" name="TextBox 23"/>
+              <a:t>EC2 Security Group explanation (port 8025 = CloudFront prefix list only; port 1025 = internal CIDR for app servers)</a:t>
+            </a:r>
+          </a:p>
+        </p:txBody>
+      </p:sp>
+      <p:sp>
+        <p:nvSpPr>
+          <p:cNvPr id="23" name="TextBox 22"/>
           <p:cNvSpPr txBox="1"/>
           <p:nvPr/>
         </p:nvSpPr>
         <p:spPr>
           <a:xfrm>
-            <a:off x="274320" y="4736592"/>
-            <a:ext cx="365760" cy="411480"/>
+            <a:off x="274320" y="6035040"/>
+            <a:ext cx="11612880" cy="502920"/>
           </a:xfrm>
           <a:prstGeom prst="rect">
             <a:avLst/>
@@ -6608,116 +6636,14 @@
           </a:bodyPr>
           <a:lstStyle/>
           <a:p>
-            <a:pPr algn="ctr"/>
-            <a:r>
-              <a:rPr sz="1400" b="1">
-                <a:solidFill>
-                  <a:srgbClr val="FFFFFF"/>
+            <a:pPr algn="l"/>
+            <a:r>
+              <a:rPr sz="1100" b="1">
+                <a:solidFill>
+                  <a:srgbClr val="1F497D"/>
                 </a:solidFill>
               </a:rPr>
-              <a:t>✓</a:t>
-            </a:r>
-          </a:p>
-        </p:txBody>
-      </p:sp>
-      <p:sp>
-        <p:nvSpPr>
-          <p:cNvPr id="25" name="TextBox 24"/>
-          <p:cNvSpPr txBox="1"/>
-          <p:nvPr/>
-        </p:nvSpPr>
-        <p:spPr>
-          <a:xfrm>
-            <a:off x="777240" y="4782312"/>
-            <a:ext cx="11064240" cy="411480"/>
-          </a:xfrm>
-          <a:prstGeom prst="rect">
-            <a:avLst/>
-          </a:prstGeom>
-          <a:noFill/>
-        </p:spPr>
-        <p:txBody>
-          <a:bodyPr wrap="square">
-            <a:spAutoFit/>
-          </a:bodyPr>
-          <a:lstStyle/>
-          <a:p>
-            <a:pPr algn="l"/>
-            <a:r>
-              <a:rPr sz="1100" b="0">
-                <a:solidFill>
-                  <a:srgbClr val="222222"/>
-                </a:solidFill>
-              </a:rPr>
-              <a:t>Flow arrows — showing full path: Staff Notebook → WOG Domain → Route 53 → CloudFront → WAF → ALB → Mailpit EC2</a:t>
-            </a:r>
-          </a:p>
-        </p:txBody>
-      </p:sp>
-      <p:sp>
-        <p:nvSpPr>
-          <p:cNvPr id="26" name="TextBox 25"/>
-          <p:cNvSpPr txBox="1"/>
-          <p:nvPr/>
-        </p:nvSpPr>
-        <p:spPr>
-          <a:xfrm>
-            <a:off x="274320" y="5394960"/>
-            <a:ext cx="11612880" cy="320040"/>
-          </a:xfrm>
-          <a:prstGeom prst="rect">
-            <a:avLst/>
-          </a:prstGeom>
-          <a:noFill/>
-        </p:spPr>
-        <p:txBody>
-          <a:bodyPr wrap="square">
-            <a:spAutoFit/>
-          </a:bodyPr>
-          <a:lstStyle/>
-          <a:p>
-            <a:pPr algn="l"/>
-            <a:r>
-              <a:rPr sz="1300" b="1">
-                <a:solidFill>
-                  <a:srgbClr val="1F497D"/>
-                </a:solidFill>
-              </a:rPr>
-              <a:t>Question answered (Slide 4):</a:t>
-            </a:r>
-          </a:p>
-        </p:txBody>
-      </p:sp>
-      <p:sp>
-        <p:nvSpPr>
-          <p:cNvPr id="27" name="TextBox 26"/>
-          <p:cNvSpPr txBox="1"/>
-          <p:nvPr/>
-        </p:nvSpPr>
-        <p:spPr>
-          <a:xfrm>
-            <a:off x="274320" y="5760720"/>
-            <a:ext cx="11612880" cy="640080"/>
-          </a:xfrm>
-          <a:prstGeom prst="rect">
-            <a:avLst/>
-          </a:prstGeom>
-          <a:noFill/>
-        </p:spPr>
-        <p:txBody>
-          <a:bodyPr wrap="square">
-            <a:spAutoFit/>
-          </a:bodyPr>
-          <a:lstStyle/>
-          <a:p>
-            <a:pPr algn="l"/>
-            <a:r>
-              <a:rPr sz="1100" b="0">
-                <a:solidFill>
-                  <a:srgbClr val="222222"/>
-                </a:solidFill>
-              </a:rPr>
-              <a:t>Yes — intranet user IPs can (and should) be listed in an AWS WAF IP Allowlist. Obtain the WOG/GSIB internet gateway egress CIDRs from GovTech / your network team and add them to the WAF IP set.</a:t>
+              <a:t>Result: simpler architecture, ~$25/month cheaper (no ALB), same security posture via WAF + SG prefix list.</a:t>
             </a:r>
           </a:p>
         </p:txBody>

</xml_diff>

<commit_message>
v7: Replace dedicated Mailpit WAF with shared existing WAF WebACL
Remove standalone mailpit-waf cell; show existing WAF WebACL (already
protecting the 3 court CDNs) being reused for Mailpit CloudFront.
One WebACL, one IP set to maintain — no duplicate rule management.
</commit_message>
<xml_diff>
--- a/infrastructure/mailpit/Mailpit_Architecture_Update.pptx
+++ b/infrastructure/mailpit/Mailpit_Architecture_Update.pptx
@@ -3198,7 +3198,7 @@
                   <a:srgbClr val="AACCFF"/>
                 </a:solidFill>
               </a:rPr>
-              <a:t>Internet Access Architecture for Intranet Staff (No ALB)</a:t>
+              <a:t>Internet Access Architecture — Shared WAF WebACL (v7)</a:t>
             </a:r>
           </a:p>
         </p:txBody>
@@ -3232,7 +3232,7 @@
                   <a:srgbClr val="88AACC"/>
                 </a:solidFill>
               </a:rPr>
-              <a:t>UAT  |  ap-southeast-1  |  CloudFront → EC2 (direct)</a:t>
+              <a:t>UAT  |  ap-southeast-1  |  CloudFront → EC2 (direct, no ALB)  |  Reuse existing WAF</a:t>
             </a:r>
           </a:p>
         </p:txBody>
@@ -3327,7 +3327,7 @@
                   <a:srgbClr val="FFFFFF"/>
                 </a:solidFill>
               </a:rPr>
-              <a:t>Architecture Flow — CloudFront Direct to EC2 (no ALB)</a:t>
+              <a:t>Architecture Flow — Shared WAF, CloudFront Direct to EC2</a:t>
             </a:r>
           </a:p>
         </p:txBody>
@@ -3409,7 +3409,7 @@
         <p:spPr>
           <a:xfrm>
             <a:off x="137160" y="1280160"/>
-            <a:ext cx="1737360" cy="960120"/>
+            <a:ext cx="1737360" cy="1005840"/>
           </a:xfrm>
           <a:prstGeom prst="rect">
             <a:avLst/>
@@ -3453,8 +3453,8 @@
         </p:nvSpPr>
         <p:spPr>
           <a:xfrm>
-            <a:off x="182880" y="1353312"/>
-            <a:ext cx="1645919" cy="822960"/>
+            <a:off x="182880" y="1371600"/>
+            <a:ext cx="1645919" cy="868680"/>
           </a:xfrm>
           <a:prstGeom prst="rect">
             <a:avLst/>
@@ -3489,7 +3489,7 @@
         <p:spPr>
           <a:xfrm>
             <a:off x="2057400" y="1280160"/>
-            <a:ext cx="1737360" cy="960120"/>
+            <a:ext cx="1737360" cy="1005840"/>
           </a:xfrm>
           <a:prstGeom prst="rect">
             <a:avLst/>
@@ -3533,8 +3533,8 @@
         </p:nvSpPr>
         <p:spPr>
           <a:xfrm>
-            <a:off x="2103120" y="1353312"/>
-            <a:ext cx="1645919" cy="822960"/>
+            <a:off x="2103120" y="1371600"/>
+            <a:ext cx="1645919" cy="868680"/>
           </a:xfrm>
           <a:prstGeom prst="rect">
             <a:avLst/>
@@ -3569,7 +3569,7 @@
         <p:spPr>
           <a:xfrm>
             <a:off x="3977639" y="1280160"/>
-            <a:ext cx="1737360" cy="960120"/>
+            <a:ext cx="1737360" cy="1005840"/>
           </a:xfrm>
           <a:prstGeom prst="rect">
             <a:avLst/>
@@ -3613,8 +3613,8 @@
         </p:nvSpPr>
         <p:spPr>
           <a:xfrm>
-            <a:off x="4023359" y="1353312"/>
-            <a:ext cx="1645919" cy="822960"/>
+            <a:off x="4023359" y="1371600"/>
+            <a:ext cx="1645919" cy="868680"/>
           </a:xfrm>
           <a:prstGeom prst="rect">
             <a:avLst/>
@@ -3649,7 +3649,7 @@
         <p:spPr>
           <a:xfrm>
             <a:off x="5897880" y="1280160"/>
-            <a:ext cx="1737360" cy="960120"/>
+            <a:ext cx="1737360" cy="1005840"/>
           </a:xfrm>
           <a:prstGeom prst="rect">
             <a:avLst/>
@@ -3693,8 +3693,8 @@
         </p:nvSpPr>
         <p:spPr>
           <a:xfrm>
-            <a:off x="5943600" y="1353312"/>
-            <a:ext cx="1645919" cy="822960"/>
+            <a:off x="5943600" y="1371600"/>
+            <a:ext cx="1645919" cy="868680"/>
           </a:xfrm>
           <a:prstGeom prst="rect">
             <a:avLst/>
@@ -3715,7 +3715,8 @@
                 </a:solidFill>
               </a:rPr>
               <a:t>(4) CloudFront
-(Mailpit CDN)</a:t>
+(Mailpit CDN)
++ Shared WAF</a:t>
             </a:r>
           </a:p>
         </p:txBody>
@@ -3728,88 +3729,8 @@
         </p:nvSpPr>
         <p:spPr>
           <a:xfrm>
-            <a:off x="7818120" y="1280160"/>
-            <a:ext cx="1737360" cy="960120"/>
-          </a:xfrm>
-          <a:prstGeom prst="rect">
-            <a:avLst/>
-          </a:prstGeom>
-          <a:solidFill>
-            <a:srgbClr val="FFD5D5"/>
-          </a:solidFill>
-          <a:ln w="19050">
-            <a:solidFill>
-              <a:srgbClr val="DD344C"/>
-            </a:solidFill>
-          </a:ln>
-        </p:spPr>
-        <p:style>
-          <a:lnRef idx="1">
-            <a:schemeClr val="accent1"/>
-          </a:lnRef>
-          <a:fillRef idx="3">
-            <a:schemeClr val="accent1"/>
-          </a:fillRef>
-          <a:effectRef idx="2">
-            <a:schemeClr val="accent1"/>
-          </a:effectRef>
-          <a:fontRef idx="minor">
-            <a:schemeClr val="lt1"/>
-          </a:fontRef>
-        </p:style>
-        <p:txBody>
-          <a:bodyPr rtlCol="0" anchor="ctr"/>
-          <a:lstStyle/>
-          <a:p>
-            <a:pPr algn="ctr"/>
-          </a:p>
-        </p:txBody>
-      </p:sp>
-      <p:sp>
-        <p:nvSpPr>
-          <p:cNvPr id="15" name="TextBox 14"/>
-          <p:cNvSpPr txBox="1"/>
-          <p:nvPr/>
-        </p:nvSpPr>
-        <p:spPr>
-          <a:xfrm>
-            <a:off x="7863840" y="1353312"/>
-            <a:ext cx="1645919" cy="822960"/>
-          </a:xfrm>
-          <a:prstGeom prst="rect">
-            <a:avLst/>
-          </a:prstGeom>
-          <a:noFill/>
-        </p:spPr>
-        <p:txBody>
-          <a:bodyPr wrap="square">
-            <a:spAutoFit/>
-          </a:bodyPr>
-          <a:lstStyle/>
-          <a:p>
-            <a:pPr algn="ctr"/>
-            <a:r>
-              <a:rPr sz="950" b="0">
-                <a:solidFill>
-                  <a:srgbClr val="222222"/>
-                </a:solidFill>
-              </a:rPr>
-              <a:t>(5) AWS WAF
-(IP Allowlist)</a:t>
-            </a:r>
-          </a:p>
-        </p:txBody>
-      </p:sp>
-      <p:sp>
-        <p:nvSpPr>
-          <p:cNvPr id="16" name="Rectangle 15"/>
-          <p:cNvSpPr/>
-          <p:nvPr/>
-        </p:nvSpPr>
-        <p:spPr>
-          <a:xfrm>
-            <a:off x="9738360" y="1280160"/>
-            <a:ext cx="2286000" cy="960120"/>
+            <a:off x="8869680" y="1280160"/>
+            <a:ext cx="2286000" cy="1005840"/>
           </a:xfrm>
           <a:prstGeom prst="rect">
             <a:avLst/>
@@ -3847,14 +3768,14 @@
       </p:sp>
       <p:sp>
         <p:nvSpPr>
-          <p:cNvPr id="17" name="TextBox 16"/>
+          <p:cNvPr id="15" name="TextBox 14"/>
           <p:cNvSpPr txBox="1"/>
           <p:nvPr/>
         </p:nvSpPr>
         <p:spPr>
           <a:xfrm>
-            <a:off x="9784080" y="1353312"/>
-            <a:ext cx="2194560" cy="822960"/>
+            <a:off x="8915400" y="1371600"/>
+            <a:ext cx="2194560" cy="868680"/>
           </a:xfrm>
           <a:prstGeom prst="rect">
             <a:avLst/>
@@ -3874,7 +3795,7 @@
                   <a:srgbClr val="222222"/>
                 </a:solidFill>
               </a:rPr>
-              <a:t>(6) Mailpit EC2
+              <a:t>(5) Mailpit EC2
 (EIP:8025)
 Email Capture</a:t>
             </a:r>
@@ -3883,7 +3804,7 @@
       </p:sp>
       <p:sp>
         <p:nvSpPr>
-          <p:cNvPr id="18" name="TextBox 17"/>
+          <p:cNvPr id="16" name="TextBox 15"/>
           <p:cNvSpPr txBox="1"/>
           <p:nvPr/>
         </p:nvSpPr>
@@ -3917,7 +3838,7 @@
       </p:sp>
       <p:sp>
         <p:nvSpPr>
-          <p:cNvPr id="19" name="TextBox 18"/>
+          <p:cNvPr id="17" name="TextBox 16"/>
           <p:cNvSpPr txBox="1"/>
           <p:nvPr/>
         </p:nvSpPr>
@@ -3951,7 +3872,7 @@
       </p:sp>
       <p:sp>
         <p:nvSpPr>
-          <p:cNvPr id="20" name="TextBox 19"/>
+          <p:cNvPr id="18" name="TextBox 17"/>
           <p:cNvSpPr txBox="1"/>
           <p:nvPr/>
         </p:nvSpPr>
@@ -3985,13 +3906,13 @@
       </p:sp>
       <p:sp>
         <p:nvSpPr>
-          <p:cNvPr id="21" name="TextBox 20"/>
+          <p:cNvPr id="19" name="TextBox 18"/>
           <p:cNvSpPr txBox="1"/>
           <p:nvPr/>
         </p:nvSpPr>
         <p:spPr>
           <a:xfrm>
-            <a:off x="7653527" y="1645920"/>
+            <a:off x="8705088" y="1645920"/>
             <a:ext cx="182880" cy="274320"/>
           </a:xfrm>
           <a:prstGeom prst="rect">
@@ -4019,58 +3940,24 @@
       </p:sp>
       <p:sp>
         <p:nvSpPr>
-          <p:cNvPr id="22" name="TextBox 21"/>
-          <p:cNvSpPr txBox="1"/>
-          <p:nvPr/>
-        </p:nvSpPr>
-        <p:spPr>
-          <a:xfrm>
-            <a:off x="9573768" y="1645920"/>
-            <a:ext cx="182880" cy="274320"/>
-          </a:xfrm>
-          <a:prstGeom prst="rect">
-            <a:avLst/>
-          </a:prstGeom>
-          <a:noFill/>
-        </p:spPr>
-        <p:txBody>
-          <a:bodyPr wrap="square">
-            <a:spAutoFit/>
-          </a:bodyPr>
-          <a:lstStyle/>
-          <a:p>
-            <a:pPr algn="ctr"/>
-            <a:r>
-              <a:rPr sz="1600" b="1">
-                <a:solidFill>
-                  <a:srgbClr val="2382B8"/>
-                </a:solidFill>
-              </a:rPr>
-              <a:t>→</a:t>
-            </a:r>
-          </a:p>
-        </p:txBody>
-      </p:sp>
-      <p:sp>
-        <p:nvSpPr>
-          <p:cNvPr id="23" name="Rectangle 22"/>
+          <p:cNvPr id="20" name="Rectangle 19"/>
           <p:cNvSpPr/>
           <p:nvPr/>
         </p:nvSpPr>
         <p:spPr>
           <a:xfrm>
-            <a:off x="5577840" y="2468880"/>
-            <a:ext cx="4389120" cy="777240"/>
+            <a:off x="5577840" y="2514600"/>
+            <a:ext cx="2926080" cy="960120"/>
           </a:xfrm>
           <a:prstGeom prst="rect">
             <a:avLst/>
           </a:prstGeom>
           <a:solidFill>
-            <a:srgbClr val="FFF2CC"/>
+            <a:srgbClr val="FFE8E8"/>
           </a:solidFill>
           <a:ln w="19050">
             <a:solidFill>
-              <a:srgbClr val="D6B656"/>
+              <a:srgbClr val="DD344C"/>
             </a:solidFill>
           </a:ln>
         </p:spPr>
@@ -4098,14 +3985,14 @@
       </p:sp>
       <p:sp>
         <p:nvSpPr>
-          <p:cNvPr id="24" name="TextBox 23"/>
+          <p:cNvPr id="21" name="TextBox 20"/>
           <p:cNvSpPr txBox="1"/>
           <p:nvPr/>
         </p:nvSpPr>
         <p:spPr>
           <a:xfrm>
-            <a:off x="5623560" y="2514600"/>
-            <a:ext cx="4297680" cy="713232"/>
+            <a:off x="5623560" y="2542032"/>
+            <a:ext cx="2834640" cy="320040"/>
           </a:xfrm>
           <a:prstGeom prst="rect">
             <a:avLst/>
@@ -4120,28 +4007,64 @@
           <a:p>
             <a:pPr algn="ctr"/>
             <a:r>
+              <a:rPr sz="1000" b="1">
+                <a:solidFill>
+                  <a:srgbClr val="DD344C"/>
+                </a:solidFill>
+              </a:rPr>
+              <a:t>Existing WAF WebACL (Shared)</a:t>
+            </a:r>
+          </a:p>
+        </p:txBody>
+      </p:sp>
+      <p:sp>
+        <p:nvSpPr>
+          <p:cNvPr id="22" name="TextBox 21"/>
+          <p:cNvSpPr txBox="1"/>
+          <p:nvPr/>
+        </p:nvSpPr>
+        <p:spPr>
+          <a:xfrm>
+            <a:off x="5669280" y="2834640"/>
+            <a:ext cx="2743200" cy="594360"/>
+          </a:xfrm>
+          <a:prstGeom prst="rect">
+            <a:avLst/>
+          </a:prstGeom>
+          <a:noFill/>
+        </p:spPr>
+        <p:txBody>
+          <a:bodyPr wrap="square">
+            <a:spAutoFit/>
+          </a:bodyPr>
+          <a:lstStyle/>
+          <a:p>
+            <a:pPr algn="l"/>
+            <a:r>
               <a:rPr sz="900" b="0">
                 <a:solidFill>
-                  <a:srgbClr val="554400"/>
+                  <a:srgbClr val="551111"/>
                 </a:solidFill>
               </a:rPr>
-              <a:t>Firewall Rule: Allow HTTPS (443) from CloudFront
-managed prefix list directly to EC2 SG port 8025.
-No ALB required — CloudFront custom origin = EIP:8025</a:t>
-            </a:r>
-          </a:p>
-        </p:txBody>
-      </p:sp>
-      <p:sp>
-        <p:nvSpPr>
-          <p:cNvPr id="25" name="Rectangle 24"/>
+              <a:t>Same WebACL already used by:
+  • Supreme Court CDN
+  • Family Justice Courts CDN
+  • State Courts CDN
+Just attach Mailpit CloudFront to it.</a:t>
+            </a:r>
+          </a:p>
+        </p:txBody>
+      </p:sp>
+      <p:sp>
+        <p:nvSpPr>
+          <p:cNvPr id="23" name="Rectangle 22"/>
           <p:cNvSpPr/>
           <p:nvPr/>
         </p:nvSpPr>
         <p:spPr>
           <a:xfrm>
-            <a:off x="137160" y="2468880"/>
-            <a:ext cx="5303520" cy="777240"/>
+            <a:off x="137160" y="2514600"/>
+            <a:ext cx="5303520" cy="960120"/>
           </a:xfrm>
           <a:prstGeom prst="rect">
             <a:avLst/>
@@ -4179,14 +4102,14 @@
       </p:sp>
       <p:sp>
         <p:nvSpPr>
-          <p:cNvPr id="26" name="TextBox 25"/>
+          <p:cNvPr id="24" name="TextBox 23"/>
           <p:cNvSpPr txBox="1"/>
           <p:nvPr/>
         </p:nvSpPr>
         <p:spPr>
           <a:xfrm>
-            <a:off x="182880" y="2514600"/>
-            <a:ext cx="5120640" cy="713232"/>
+            <a:off x="182880" y="2542032"/>
+            <a:ext cx="5212080" cy="292608"/>
           </a:xfrm>
           <a:prstGeom prst="rect">
             <a:avLst/>
@@ -4199,6 +4122,40 @@
           </a:bodyPr>
           <a:lstStyle/>
           <a:p>
+            <a:pPr algn="ctr"/>
+            <a:r>
+              <a:rPr sz="1000" b="1">
+                <a:solidFill>
+                  <a:srgbClr val="248814"/>
+                </a:solidFill>
+              </a:rPr>
+              <a:t>EC2 Security Group</a:t>
+            </a:r>
+          </a:p>
+        </p:txBody>
+      </p:sp>
+      <p:sp>
+        <p:nvSpPr>
+          <p:cNvPr id="25" name="TextBox 24"/>
+          <p:cNvSpPr txBox="1"/>
+          <p:nvPr/>
+        </p:nvSpPr>
+        <p:spPr>
+          <a:xfrm>
+            <a:off x="182880" y="2834640"/>
+            <a:ext cx="5212080" cy="594360"/>
+          </a:xfrm>
+          <a:prstGeom prst="rect">
+            <a:avLst/>
+          </a:prstGeom>
+          <a:noFill/>
+        </p:spPr>
+        <p:txBody>
+          <a:bodyPr wrap="square">
+            <a:spAutoFit/>
+          </a:bodyPr>
+          <a:lstStyle/>
+          <a:p>
             <a:pPr algn="l"/>
             <a:r>
               <a:rPr sz="900" b="0">
@@ -4206,9 +4163,9 @@
                   <a:srgbClr val="114411"/>
                 </a:solidFill>
               </a:rPr>
-              <a:t>EC2 Security Group:
- • Port 8025 (web UI) — allow from CloudFront prefix list only
- • Port 1025 (SMTP)   — allow from internal VPC CIDR (app servers)</a:t>
+              <a:t>Port 8025 (web UI)  — Allow from CloudFront managed prefix list only
+Port 1025 (SMTP)    — Allow from internal VPC CIDR (app servers)
+Firewall rule: HTTPS (443) from CloudFront prefix list → EC2:8025</a:t>
             </a:r>
           </a:p>
         </p:txBody>
@@ -4303,21 +4260,55 @@
                   <a:srgbClr val="FFFFFF"/>
                 </a:solidFill>
               </a:rPr>
-              <a:t>New Components (v6 — No ALB)</a:t>
-            </a:r>
-          </a:p>
-        </p:txBody>
-      </p:sp>
-      <p:sp>
-        <p:nvSpPr>
-          <p:cNvPr id="4" name="Rectangle 3"/>
+              <a:t>Shared WAF WebACL — How It Works</a:t>
+            </a:r>
+          </a:p>
+        </p:txBody>
+      </p:sp>
+      <p:sp>
+        <p:nvSpPr>
+          <p:cNvPr id="4" name="TextBox 3"/>
+          <p:cNvSpPr txBox="1"/>
+          <p:nvPr/>
+        </p:nvSpPr>
+        <p:spPr>
+          <a:xfrm>
+            <a:off x="274320" y="804672"/>
+            <a:ext cx="11612880" cy="347472"/>
+          </a:xfrm>
+          <a:prstGeom prst="rect">
+            <a:avLst/>
+          </a:prstGeom>
+          <a:noFill/>
+        </p:spPr>
+        <p:txBody>
+          <a:bodyPr wrap="square">
+            <a:spAutoFit/>
+          </a:bodyPr>
+          <a:lstStyle/>
+          <a:p>
+            <a:pPr algn="l"/>
+            <a:r>
+              <a:rPr sz="1300" b="1">
+                <a:solidFill>
+                  <a:srgbClr val="1F497D"/>
+                </a:solidFill>
+              </a:rPr>
+              <a:t>Why reuse the existing WAF WebACL?</a:t>
+            </a:r>
+          </a:p>
+        </p:txBody>
+      </p:sp>
+      <p:sp>
+        <p:nvSpPr>
+          <p:cNvPr id="5" name="Rectangle 4"/>
           <p:cNvSpPr/>
           <p:nvPr/>
         </p:nvSpPr>
         <p:spPr>
           <a:xfrm>
-            <a:off x="182880" y="804672"/>
-            <a:ext cx="2103120" cy="868680"/>
+            <a:off x="274320" y="1234440"/>
+            <a:ext cx="1371600" cy="731520"/>
           </a:xfrm>
           <a:prstGeom prst="rect">
             <a:avLst/>
@@ -4355,14 +4346,14 @@
       </p:sp>
       <p:sp>
         <p:nvSpPr>
-          <p:cNvPr id="5" name="TextBox 4"/>
+          <p:cNvPr id="6" name="TextBox 5"/>
           <p:cNvSpPr txBox="1"/>
           <p:nvPr/>
         </p:nvSpPr>
         <p:spPr>
           <a:xfrm>
-            <a:off x="228600" y="941832"/>
-            <a:ext cx="2011680" cy="594360"/>
+            <a:off x="320040" y="1399032"/>
+            <a:ext cx="1280160" cy="457200"/>
           </a:xfrm>
           <a:prstGeom prst="rect">
             <a:avLst/>
@@ -4377,26 +4368,26 @@
           <a:p>
             <a:pPr algn="ctr"/>
             <a:r>
-              <a:rPr sz="1100" b="1">
-                <a:solidFill>
-                  <a:srgbClr val="111155"/>
+              <a:rPr sz="1200" b="1">
+                <a:solidFill>
+                  <a:srgbClr val="1F497D"/>
                 </a:solidFill>
               </a:rPr>
-              <a:t>WOG Domain</a:t>
-            </a:r>
-          </a:p>
-        </p:txBody>
-      </p:sp>
-      <p:sp>
-        <p:nvSpPr>
-          <p:cNvPr id="6" name="TextBox 5"/>
+              <a:t>Cost</a:t>
+            </a:r>
+          </a:p>
+        </p:txBody>
+      </p:sp>
+      <p:sp>
+        <p:nvSpPr>
+          <p:cNvPr id="7" name="TextBox 6"/>
           <p:cNvSpPr txBox="1"/>
           <p:nvPr/>
         </p:nvSpPr>
         <p:spPr>
           <a:xfrm>
-            <a:off x="2423160" y="896112"/>
-            <a:ext cx="9555480" cy="731520"/>
+            <a:off x="1783080" y="1344168"/>
+            <a:ext cx="10149840" cy="621792"/>
           </a:xfrm>
           <a:prstGeom prst="rect">
             <a:avLst/>
@@ -4411,36 +4402,36 @@
           <a:p>
             <a:pPr algn="l"/>
             <a:r>
-              <a:rPr sz="1000" b="0">
+              <a:rPr sz="1100" b="0">
                 <a:solidFill>
                   <a:srgbClr val="222222"/>
                 </a:solidFill>
               </a:rPr>
-              <a:t>Public internet-facing DNS name (e.g. mailpit.example.gov.sg) under the Whole-of-Government domain. Registered in Route 53 and pointed at the CloudFront distribution as an A alias record.</a:t>
-            </a:r>
-          </a:p>
-        </p:txBody>
-      </p:sp>
-      <p:sp>
-        <p:nvSpPr>
-          <p:cNvPr id="7" name="Rectangle 6"/>
+              <a:t>A WAF WebACL can be associated with multiple CloudFront distributions at no extra charge per distribution. There is no benefit to creating a separate WebACL for Mailpit.</a:t>
+            </a:r>
+          </a:p>
+        </p:txBody>
+      </p:sp>
+      <p:sp>
+        <p:nvSpPr>
+          <p:cNvPr id="8" name="Rectangle 7"/>
           <p:cNvSpPr/>
           <p:nvPr/>
         </p:nvSpPr>
         <p:spPr>
           <a:xfrm>
-            <a:off x="182880" y="1737360"/>
-            <a:ext cx="2103120" cy="868680"/>
+            <a:off x="274320" y="2057400"/>
+            <a:ext cx="1371600" cy="731520"/>
           </a:xfrm>
           <a:prstGeom prst="rect">
             <a:avLst/>
           </a:prstGeom>
           <a:solidFill>
-            <a:srgbClr val="E8D5FF"/>
+            <a:srgbClr val="DAE8FC"/>
           </a:solidFill>
           <a:ln w="19050">
             <a:solidFill>
-              <a:srgbClr val="8C4FFF"/>
+              <a:srgbClr val="6C8EBF"/>
             </a:solidFill>
           </a:ln>
         </p:spPr>
@@ -4468,14 +4459,14 @@
       </p:sp>
       <p:sp>
         <p:nvSpPr>
-          <p:cNvPr id="8" name="TextBox 7"/>
+          <p:cNvPr id="9" name="TextBox 8"/>
           <p:cNvSpPr txBox="1"/>
           <p:nvPr/>
         </p:nvSpPr>
         <p:spPr>
           <a:xfrm>
-            <a:off x="228600" y="1874519"/>
-            <a:ext cx="2011680" cy="594360"/>
+            <a:off x="320040" y="2221992"/>
+            <a:ext cx="1280160" cy="457200"/>
           </a:xfrm>
           <a:prstGeom prst="rect">
             <a:avLst/>
@@ -4490,26 +4481,26 @@
           <a:p>
             <a:pPr algn="ctr"/>
             <a:r>
-              <a:rPr sz="1100" b="1">
-                <a:solidFill>
-                  <a:srgbClr val="111155"/>
+              <a:rPr sz="1200" b="1">
+                <a:solidFill>
+                  <a:srgbClr val="1F497D"/>
                 </a:solidFill>
               </a:rPr>
-              <a:t>Route 53</a:t>
-            </a:r>
-          </a:p>
-        </p:txBody>
-      </p:sp>
-      <p:sp>
-        <p:nvSpPr>
-          <p:cNvPr id="9" name="TextBox 8"/>
+              <a:t>Consistency</a:t>
+            </a:r>
+          </a:p>
+        </p:txBody>
+      </p:sp>
+      <p:sp>
+        <p:nvSpPr>
+          <p:cNvPr id="10" name="TextBox 9"/>
           <p:cNvSpPr txBox="1"/>
           <p:nvPr/>
         </p:nvSpPr>
         <p:spPr>
           <a:xfrm>
-            <a:off x="2423160" y="1828800"/>
-            <a:ext cx="9555480" cy="731520"/>
+            <a:off x="1783080" y="2167128"/>
+            <a:ext cx="10149840" cy="621792"/>
           </a:xfrm>
           <a:prstGeom prst="rect">
             <a:avLst/>
@@ -4524,36 +4515,36 @@
           <a:p>
             <a:pPr algn="l"/>
             <a:r>
-              <a:rPr sz="1000" b="0">
+              <a:rPr sz="1100" b="0">
                 <a:solidFill>
                   <a:srgbClr val="222222"/>
                 </a:solidFill>
               </a:rPr>
-              <a:t>AWS hosted zone for the WOG domain. Resolves the domain to the CloudFront distribution's domain name so that browser requests reach CloudFront first.</a:t>
-            </a:r>
-          </a:p>
-        </p:txBody>
-      </p:sp>
-      <p:sp>
-        <p:nvSpPr>
-          <p:cNvPr id="10" name="Rectangle 9"/>
+              <a:t>The existing WebACL already has the WOG/GSIB IP allowlist rules configured for the court CDNs. Adding the Mailpit CloudFront inherits those same rules instantly.</a:t>
+            </a:r>
+          </a:p>
+        </p:txBody>
+      </p:sp>
+      <p:sp>
+        <p:nvSpPr>
+          <p:cNvPr id="11" name="Rectangle 10"/>
           <p:cNvSpPr/>
           <p:nvPr/>
         </p:nvSpPr>
         <p:spPr>
           <a:xfrm>
-            <a:off x="182880" y="2670048"/>
-            <a:ext cx="2103120" cy="868680"/>
+            <a:off x="274320" y="2880360"/>
+            <a:ext cx="1371600" cy="731520"/>
           </a:xfrm>
           <a:prstGeom prst="rect">
             <a:avLst/>
           </a:prstGeom>
           <a:solidFill>
-            <a:srgbClr val="FFD5EA"/>
+            <a:srgbClr val="DAE8FC"/>
           </a:solidFill>
           <a:ln w="19050">
             <a:solidFill>
-              <a:srgbClr val="E7157B"/>
+              <a:srgbClr val="6C8EBF"/>
             </a:solidFill>
           </a:ln>
         </p:spPr>
@@ -4581,14 +4572,14 @@
       </p:sp>
       <p:sp>
         <p:nvSpPr>
-          <p:cNvPr id="11" name="TextBox 10"/>
+          <p:cNvPr id="12" name="TextBox 11"/>
           <p:cNvSpPr txBox="1"/>
           <p:nvPr/>
         </p:nvSpPr>
         <p:spPr>
           <a:xfrm>
-            <a:off x="228600" y="2807208"/>
-            <a:ext cx="2011680" cy="594360"/>
+            <a:off x="320040" y="3044952"/>
+            <a:ext cx="1280160" cy="457200"/>
           </a:xfrm>
           <a:prstGeom prst="rect">
             <a:avLst/>
@@ -4603,26 +4594,26 @@
           <a:p>
             <a:pPr algn="ctr"/>
             <a:r>
-              <a:rPr sz="1100" b="1">
-                <a:solidFill>
-                  <a:srgbClr val="111155"/>
+              <a:rPr sz="1200" b="1">
+                <a:solidFill>
+                  <a:srgbClr val="1F497D"/>
                 </a:solidFill>
               </a:rPr>
-              <a:t>CloudFront Distribution</a:t>
-            </a:r>
-          </a:p>
-        </p:txBody>
-      </p:sp>
-      <p:sp>
-        <p:nvSpPr>
-          <p:cNvPr id="12" name="TextBox 11"/>
+              <a:t>Simplicity</a:t>
+            </a:r>
+          </a:p>
+        </p:txBody>
+      </p:sp>
+      <p:sp>
+        <p:nvSpPr>
+          <p:cNvPr id="13" name="TextBox 12"/>
           <p:cNvSpPr txBox="1"/>
           <p:nvPr/>
         </p:nvSpPr>
         <p:spPr>
           <a:xfrm>
-            <a:off x="2423160" y="2761488"/>
-            <a:ext cx="9555480" cy="731520"/>
+            <a:off x="1783080" y="2990088"/>
+            <a:ext cx="10149840" cy="621792"/>
           </a:xfrm>
           <a:prstGeom prst="rect">
             <a:avLst/>
@@ -4637,58 +4628,13 @@
           <a:p>
             <a:pPr algn="l"/>
             <a:r>
-              <a:rPr sz="1000" b="0">
+              <a:rPr sz="1100" b="0">
                 <a:solidFill>
                   <a:srgbClr val="222222"/>
                 </a:solidFill>
               </a:rPr>
-              <a:t>Terminates HTTPS from WOG notebook users. Custom origin = Mailpit Elastic IP on port 8025 (HTTP). CloudFront handles TLS, WAF enforcement, and caching (caching should be DISABLED for Mailpit UI).</a:t>
-            </a:r>
-          </a:p>
-        </p:txBody>
-      </p:sp>
-      <p:sp>
-        <p:nvSpPr>
-          <p:cNvPr id="13" name="Rectangle 12"/>
-          <p:cNvSpPr/>
-          <p:nvPr/>
-        </p:nvSpPr>
-        <p:spPr>
-          <a:xfrm>
-            <a:off x="182880" y="3602736"/>
-            <a:ext cx="2103120" cy="868680"/>
-          </a:xfrm>
-          <a:prstGeom prst="rect">
-            <a:avLst/>
-          </a:prstGeom>
-          <a:solidFill>
-            <a:srgbClr val="FFD5D5"/>
-          </a:solidFill>
-          <a:ln w="19050">
-            <a:solidFill>
-              <a:srgbClr val="DD344C"/>
-            </a:solidFill>
-          </a:ln>
-        </p:spPr>
-        <p:style>
-          <a:lnRef idx="1">
-            <a:schemeClr val="accent1"/>
-          </a:lnRef>
-          <a:fillRef idx="3">
-            <a:schemeClr val="accent1"/>
-          </a:fillRef>
-          <a:effectRef idx="2">
-            <a:schemeClr val="accent1"/>
-          </a:effectRef>
-          <a:fontRef idx="minor">
-            <a:schemeClr val="lt1"/>
-          </a:fontRef>
-        </p:style>
-        <p:txBody>
-          <a:bodyPr rtlCol="0" anchor="ctr"/>
-          <a:lstStyle/>
-          <a:p>
-            <a:pPr algn="ctr"/>
+              <a:t>One WebACL to manage. If WOG egress IPs change, updating the IP set once covers all CDNs including Mailpit — no duplicate rule maintenance.</a:t>
+            </a:r>
           </a:p>
         </p:txBody>
       </p:sp>
@@ -4700,8 +4646,8 @@
         </p:nvSpPr>
         <p:spPr>
           <a:xfrm>
-            <a:off x="228600" y="3739896"/>
-            <a:ext cx="2011680" cy="594360"/>
+            <a:off x="274320" y="3767328"/>
+            <a:ext cx="11612880" cy="320040"/>
           </a:xfrm>
           <a:prstGeom prst="rect">
             <a:avLst/>
@@ -4714,175 +4660,28 @@
           </a:bodyPr>
           <a:lstStyle/>
           <a:p>
-            <a:pPr algn="ctr"/>
-            <a:r>
-              <a:rPr sz="1100" b="1">
-                <a:solidFill>
-                  <a:srgbClr val="111155"/>
+            <a:pPr algn="l"/>
+            <a:r>
+              <a:rPr sz="1300" b="1">
+                <a:solidFill>
+                  <a:srgbClr val="1F497D"/>
                 </a:solidFill>
               </a:rPr>
-              <a:t>AWS WAF (IP Allowlist)</a:t>
-            </a:r>
-          </a:p>
-        </p:txBody>
-      </p:sp>
-      <p:sp>
-        <p:nvSpPr>
-          <p:cNvPr id="15" name="TextBox 14"/>
-          <p:cNvSpPr txBox="1"/>
-          <p:nvPr/>
-        </p:nvSpPr>
-        <p:spPr>
-          <a:xfrm>
-            <a:off x="2423160" y="3694176"/>
-            <a:ext cx="9555480" cy="731520"/>
-          </a:xfrm>
-          <a:prstGeom prst="rect">
-            <a:avLst/>
-          </a:prstGeom>
-          <a:noFill/>
-        </p:spPr>
-        <p:txBody>
-          <a:bodyPr wrap="square">
-            <a:spAutoFit/>
-          </a:bodyPr>
-          <a:lstStyle/>
-          <a:p>
-            <a:pPr algn="l"/>
-            <a:r>
-              <a:rPr sz="1000" b="0">
-                <a:solidFill>
-                  <a:srgbClr val="222222"/>
-                </a:solidFill>
-              </a:rPr>
-              <a:t>Attached to the CloudFront distribution. Default action = BLOCK. An ALLOW rule matches an IP set containing the WOG/GSIB internet gateway egress CIDRs — only government staff reach Mailpit.</a:t>
-            </a:r>
-          </a:p>
-        </p:txBody>
-      </p:sp>
-      <p:sp>
-        <p:nvSpPr>
-          <p:cNvPr id="16" name="Rectangle 15"/>
+              <a:t>What to do — one step:</a:t>
+            </a:r>
+          </a:p>
+        </p:txBody>
+      </p:sp>
+      <p:sp>
+        <p:nvSpPr>
+          <p:cNvPr id="15" name="Rectangle 14"/>
           <p:cNvSpPr/>
           <p:nvPr/>
         </p:nvSpPr>
         <p:spPr>
           <a:xfrm>
-            <a:off x="182880" y="4535424"/>
-            <a:ext cx="2103120" cy="868680"/>
-          </a:xfrm>
-          <a:prstGeom prst="rect">
-            <a:avLst/>
-          </a:prstGeom>
-          <a:solidFill>
-            <a:srgbClr val="E8FFE8"/>
-          </a:solidFill>
-          <a:ln w="19050">
-            <a:solidFill>
-              <a:srgbClr val="248814"/>
-            </a:solidFill>
-          </a:ln>
-        </p:spPr>
-        <p:style>
-          <a:lnRef idx="1">
-            <a:schemeClr val="accent1"/>
-          </a:lnRef>
-          <a:fillRef idx="3">
-            <a:schemeClr val="accent1"/>
-          </a:fillRef>
-          <a:effectRef idx="2">
-            <a:schemeClr val="accent1"/>
-          </a:effectRef>
-          <a:fontRef idx="minor">
-            <a:schemeClr val="lt1"/>
-          </a:fontRef>
-        </p:style>
-        <p:txBody>
-          <a:bodyPr rtlCol="0" anchor="ctr"/>
-          <a:lstStyle/>
-          <a:p>
-            <a:pPr algn="ctr"/>
-          </a:p>
-        </p:txBody>
-      </p:sp>
-      <p:sp>
-        <p:nvSpPr>
-          <p:cNvPr id="17" name="TextBox 16"/>
-          <p:cNvSpPr txBox="1"/>
-          <p:nvPr/>
-        </p:nvSpPr>
-        <p:spPr>
-          <a:xfrm>
-            <a:off x="228600" y="4672584"/>
-            <a:ext cx="2011680" cy="594360"/>
-          </a:xfrm>
-          <a:prstGeom prst="rect">
-            <a:avLst/>
-          </a:prstGeom>
-          <a:noFill/>
-        </p:spPr>
-        <p:txBody>
-          <a:bodyPr wrap="square">
-            <a:spAutoFit/>
-          </a:bodyPr>
-          <a:lstStyle/>
-          <a:p>
-            <a:pPr algn="ctr"/>
-            <a:r>
-              <a:rPr sz="1100" b="1">
-                <a:solidFill>
-                  <a:srgbClr val="111155"/>
-                </a:solidFill>
-              </a:rPr>
-              <a:t>EC2 Security Group</a:t>
-            </a:r>
-          </a:p>
-        </p:txBody>
-      </p:sp>
-      <p:sp>
-        <p:nvSpPr>
-          <p:cNvPr id="18" name="TextBox 17"/>
-          <p:cNvSpPr txBox="1"/>
-          <p:nvPr/>
-        </p:nvSpPr>
-        <p:spPr>
-          <a:xfrm>
-            <a:off x="2423160" y="4626864"/>
-            <a:ext cx="9555480" cy="731520"/>
-          </a:xfrm>
-          <a:prstGeom prst="rect">
-            <a:avLst/>
-          </a:prstGeom>
-          <a:noFill/>
-        </p:spPr>
-        <p:txBody>
-          <a:bodyPr wrap="square">
-            <a:spAutoFit/>
-          </a:bodyPr>
-          <a:lstStyle/>
-          <a:p>
-            <a:pPr algn="l"/>
-            <a:r>
-              <a:rPr sz="1000" b="0">
-                <a:solidFill>
-                  <a:srgbClr val="222222"/>
-                </a:solidFill>
-              </a:rPr>
-              <a:t>Port 8025 inbound: SourcePrefixListId = CloudFront origin-facing managed prefix list (com.amazonaws.global.cloudfront.origin-facing). This ensures ONLY CloudFront can hit the UI — no direct access bypassing WAF. Port 1025: internal CIDR for app servers sending test mail.</a:t>
-            </a:r>
-          </a:p>
-        </p:txBody>
-      </p:sp>
-      <p:sp>
-        <p:nvSpPr>
-          <p:cNvPr id="19" name="Rectangle 18"/>
-          <p:cNvSpPr/>
-          <p:nvPr/>
-        </p:nvSpPr>
-        <p:spPr>
-          <a:xfrm>
-            <a:off x="182880" y="5468112"/>
-            <a:ext cx="2103120" cy="868680"/>
+            <a:off x="274320" y="4160520"/>
+            <a:ext cx="11612880" cy="1005840"/>
           </a:xfrm>
           <a:prstGeom prst="rect">
             <a:avLst/>
@@ -4920,14 +4719,14 @@
       </p:sp>
       <p:sp>
         <p:nvSpPr>
-          <p:cNvPr id="20" name="TextBox 19"/>
+          <p:cNvPr id="16" name="TextBox 15"/>
           <p:cNvSpPr txBox="1"/>
           <p:nvPr/>
         </p:nvSpPr>
         <p:spPr>
           <a:xfrm>
-            <a:off x="228600" y="5605272"/>
-            <a:ext cx="2011680" cy="594360"/>
+            <a:off x="365760" y="4206240"/>
+            <a:ext cx="11430000" cy="914400"/>
           </a:xfrm>
           <a:prstGeom prst="rect">
             <a:avLst/>
@@ -4940,33 +4739,40 @@
           </a:bodyPr>
           <a:lstStyle/>
           <a:p>
-            <a:pPr algn="ctr"/>
-            <a:r>
-              <a:rPr sz="1100" b="1">
-                <a:solidFill>
-                  <a:srgbClr val="111155"/>
+            <a:pPr algn="l"/>
+            <a:r>
+              <a:rPr sz="1000" b="0">
+                <a:solidFill>
+                  <a:srgbClr val="332200"/>
                 </a:solidFill>
               </a:rPr>
-              <a:t>Firewall Rule</a:t>
-            </a:r>
-          </a:p>
-        </p:txBody>
-      </p:sp>
-      <p:sp>
-        <p:nvSpPr>
-          <p:cNvPr id="21" name="TextBox 20"/>
+              <a:t>In the AWS Console (or CLI):
+  1. Open the existing WAF WebACL used by the court CDNs (scope: CLOUDFRONT, region: us-east-1).
+  2. Go to Associated AWS resources → Add association → select the Mailpit CloudFront distribution.
+  3. Done — the same IP allowlist (WOG/GSIB egress IPs) now applies to Mailpit CDN too.
+CLI: aws wafv2 associate-web-acl --scope CLOUDFRONT --region us-east-1 \
+       --web-acl-arn &lt;existing-webacl-arn&gt; --resource-arn &lt;mailpit-cloudfront-arn&gt;</a:t>
+            </a:r>
+          </a:p>
+        </p:txBody>
+      </p:sp>
+      <p:sp>
+        <p:nvSpPr>
+          <p:cNvPr id="17" name="TextBox 16"/>
           <p:cNvSpPr txBox="1"/>
           <p:nvPr/>
         </p:nvSpPr>
         <p:spPr>
           <a:xfrm>
-            <a:off x="2423160" y="5559551"/>
-            <a:ext cx="9555480" cy="731520"/>
-          </a:xfrm>
-          <a:prstGeom prst="rect">
-            <a:avLst/>
-          </a:prstGeom>
-          <a:noFill/>
+            <a:off x="274320" y="5257800"/>
+            <a:ext cx="11612880" cy="457200"/>
+          </a:xfrm>
+          <a:prstGeom prst="rect">
+            <a:avLst/>
+          </a:prstGeom>
+          <a:solidFill>
+            <a:srgbClr val="FFF0E0"/>
+          </a:solidFill>
         </p:spPr>
         <p:txBody>
           <a:bodyPr wrap="square">
@@ -4978,10 +4784,10 @@
             <a:r>
               <a:rPr sz="1000" b="0">
                 <a:solidFill>
-                  <a:srgbClr val="222222"/>
+                  <a:srgbClr val="992200"/>
                 </a:solidFill>
               </a:rPr>
-              <a:t>Allow TCP 443 inbound from CloudFront to the EC2 Elastic IP on port 8025. Because CloudFront uses HTTP to the origin (within AWS), the relevant rule is allowing CloudFront prefix list → EC2 SG port 8025.</a:t>
+              <a:t>Note: WAF WebACL scope must be CLOUDFRONT and the WebACL must be in us-east-1 (this is an AWS requirement for CloudFront WAFs regardless of where your resources are).</a:t>
             </a:r>
           </a:p>
         </p:txBody>
@@ -5076,7 +4882,7 @@
                   <a:srgbClr val="FFFFFF"/>
                 </a:solidFill>
               </a:rPr>
-              <a:t>Intranet IP Allowlist — AWS WAF Configuration</a:t>
+              <a:t>Intranet IP Allowlist — WAF Configuration</a:t>
             </a:r>
           </a:p>
         </p:txBody>
@@ -5144,7 +4950,7 @@
                   <a:srgbClr val="248814"/>
                 </a:solidFill>
               </a:rPr>
-              <a:t>Yes — this is the recommended approach.</a:t>
+              <a:t>Yes — obtain WOG/GSIB egress CIDRs from GovTech/ITAS and add them to the existing WAF IP set.</a:t>
             </a:r>
           </a:p>
         </p:txBody>
@@ -5178,7 +4984,7 @@
                   <a:srgbClr val="222222"/>
                 </a:solidFill>
               </a:rPr>
-              <a:t>Intranet staff on GSIB/WOG notebooks browse the internet through the government's central internet gateway (SGWAN). Their traffic appears at CloudFront with the public egress IPs of that gateway, not individual device IPs. Add those gateway CIDRs to the WAF IP set.</a:t>
+              <a:t>When intranet staff on GSIB/WOG notebooks browse the internet, their traffic exits through the government's central internet gateway (SGWAN). CloudFront sees the public egress IPs of that gateway — not individual device IPs. Those gateway CIDRs go into the WAF IP set.</a:t>
             </a:r>
           </a:p>
         </p:txBody>
@@ -5212,21 +5018,89 @@
                   <a:srgbClr val="1F497D"/>
                 </a:solidFill>
               </a:rPr>
-              <a:t>Configuration steps:</a:t>
-            </a:r>
-          </a:p>
-        </p:txBody>
-      </p:sp>
-      <p:sp>
-        <p:nvSpPr>
-          <p:cNvPr id="8" name="Rectangle 7"/>
+              <a:t>If the IP set already exists in the WAF WebACL:</a:t>
+            </a:r>
+          </a:p>
+        </p:txBody>
+      </p:sp>
+      <p:sp>
+        <p:nvSpPr>
+          <p:cNvPr id="8" name="TextBox 7"/>
+          <p:cNvSpPr txBox="1"/>
+          <p:nvPr/>
+        </p:nvSpPr>
+        <p:spPr>
+          <a:xfrm>
+            <a:off x="274320" y="2651760"/>
+            <a:ext cx="11612880" cy="530352"/>
+          </a:xfrm>
+          <a:prstGeom prst="rect">
+            <a:avLst/>
+          </a:prstGeom>
+          <a:noFill/>
+        </p:spPr>
+        <p:txBody>
+          <a:bodyPr wrap="square">
+            <a:spAutoFit/>
+          </a:bodyPr>
+          <a:lstStyle/>
+          <a:p>
+            <a:pPr algn="l"/>
+            <a:r>
+              <a:rPr sz="1100" b="0">
+                <a:solidFill>
+                  <a:srgbClr val="222222"/>
+                </a:solidFill>
+              </a:rPr>
+              <a:t>The IP set used for the court CDNs likely already contains the WOG egress IPs. Associating Mailpit CloudFront with the same WebACL means those IPs are automatically applied — no additional IP set changes needed.</a:t>
+            </a:r>
+          </a:p>
+        </p:txBody>
+      </p:sp>
+      <p:sp>
+        <p:nvSpPr>
+          <p:cNvPr id="9" name="TextBox 8"/>
+          <p:cNvSpPr txBox="1"/>
+          <p:nvPr/>
+        </p:nvSpPr>
+        <p:spPr>
+          <a:xfrm>
+            <a:off x="274320" y="3273552"/>
+            <a:ext cx="11612880" cy="292608"/>
+          </a:xfrm>
+          <a:prstGeom prst="rect">
+            <a:avLst/>
+          </a:prstGeom>
+          <a:noFill/>
+        </p:spPr>
+        <p:txBody>
+          <a:bodyPr wrap="square">
+            <a:spAutoFit/>
+          </a:bodyPr>
+          <a:lstStyle/>
+          <a:p>
+            <a:pPr algn="l"/>
+            <a:r>
+              <a:rPr sz="1200" b="1">
+                <a:solidFill>
+                  <a:srgbClr val="1F497D"/>
+                </a:solidFill>
+              </a:rPr>
+              <a:t>If you need to add/update IPs in the WAF IP set:</a:t>
+            </a:r>
+          </a:p>
+        </p:txBody>
+      </p:sp>
+      <p:sp>
+        <p:nvSpPr>
+          <p:cNvPr id="10" name="Rectangle 9"/>
           <p:cNvSpPr/>
           <p:nvPr/>
         </p:nvSpPr>
         <p:spPr>
           <a:xfrm>
-            <a:off x="274320" y="2697480"/>
-            <a:ext cx="2286000" cy="685800"/>
+            <a:off x="274320" y="3630168"/>
+            <a:ext cx="1645920" cy="731520"/>
           </a:xfrm>
           <a:prstGeom prst="rect">
             <a:avLst/>
@@ -5264,14 +5138,14 @@
       </p:sp>
       <p:sp>
         <p:nvSpPr>
-          <p:cNvPr id="9" name="TextBox 8"/>
+          <p:cNvPr id="11" name="TextBox 10"/>
           <p:cNvSpPr txBox="1"/>
           <p:nvPr/>
         </p:nvSpPr>
         <p:spPr>
           <a:xfrm>
-            <a:off x="320040" y="2834640"/>
-            <a:ext cx="2194560" cy="438912"/>
+            <a:off x="320040" y="3813048"/>
+            <a:ext cx="1554480" cy="411480"/>
           </a:xfrm>
           <a:prstGeom prst="rect">
             <a:avLst/>
@@ -5286,26 +5160,26 @@
           <a:p>
             <a:pPr algn="ctr"/>
             <a:r>
-              <a:rPr sz="1000" b="1">
+              <a:rPr sz="1100" b="1">
                 <a:solidFill>
                   <a:srgbClr val="1F497D"/>
                 </a:solidFill>
               </a:rPr>
-              <a:t>Step 1 — Get CIDRs</a:t>
-            </a:r>
-          </a:p>
-        </p:txBody>
-      </p:sp>
-      <p:sp>
-        <p:nvSpPr>
-          <p:cNvPr id="10" name="TextBox 9"/>
+              <a:t>Get CIDRs</a:t>
+            </a:r>
+          </a:p>
+        </p:txBody>
+      </p:sp>
+      <p:sp>
+        <p:nvSpPr>
+          <p:cNvPr id="12" name="TextBox 11"/>
           <p:cNvSpPr txBox="1"/>
           <p:nvPr/>
         </p:nvSpPr>
         <p:spPr>
           <a:xfrm>
-            <a:off x="2697480" y="2770632"/>
-            <a:ext cx="9189720" cy="603504"/>
+            <a:off x="2057400" y="3721608"/>
+            <a:ext cx="9875520" cy="621792"/>
           </a:xfrm>
           <a:prstGeom prst="rect">
             <a:avLst/>
@@ -5320,26 +5194,26 @@
           <a:p>
             <a:pPr algn="l"/>
             <a:r>
-              <a:rPr sz="950" b="0">
+              <a:rPr sz="1000" b="0">
                 <a:solidFill>
                   <a:srgbClr val="222222"/>
                 </a:solidFill>
               </a:rPr>
-              <a:t>Ask your GovTech / ITAS / SGWAN network team for the public egress IP ranges (CIDRs) of the WOG internet gateway.</a:t>
-            </a:r>
-          </a:p>
-        </p:txBody>
-      </p:sp>
-      <p:sp>
-        <p:nvSpPr>
-          <p:cNvPr id="11" name="Rectangle 10"/>
+              <a:t>Ask GovTech / ITAS / SGWAN network team for the public egress IP ranges of the WOG internet gateway.</a:t>
+            </a:r>
+          </a:p>
+        </p:txBody>
+      </p:sp>
+      <p:sp>
+        <p:nvSpPr>
+          <p:cNvPr id="13" name="Rectangle 12"/>
           <p:cNvSpPr/>
           <p:nvPr/>
         </p:nvSpPr>
         <p:spPr>
           <a:xfrm>
-            <a:off x="274320" y="3456432"/>
-            <a:ext cx="2286000" cy="685800"/>
+            <a:off x="274320" y="4453128"/>
+            <a:ext cx="1645920" cy="731520"/>
           </a:xfrm>
           <a:prstGeom prst="rect">
             <a:avLst/>
@@ -5377,14 +5251,14 @@
       </p:sp>
       <p:sp>
         <p:nvSpPr>
-          <p:cNvPr id="12" name="TextBox 11"/>
+          <p:cNvPr id="14" name="TextBox 13"/>
           <p:cNvSpPr txBox="1"/>
           <p:nvPr/>
         </p:nvSpPr>
         <p:spPr>
           <a:xfrm>
-            <a:off x="320040" y="3593592"/>
-            <a:ext cx="2194560" cy="438912"/>
+            <a:off x="320040" y="4636008"/>
+            <a:ext cx="1554480" cy="411480"/>
           </a:xfrm>
           <a:prstGeom prst="rect">
             <a:avLst/>
@@ -5399,26 +5273,26 @@
           <a:p>
             <a:pPr algn="ctr"/>
             <a:r>
-              <a:rPr sz="1000" b="1">
+              <a:rPr sz="1100" b="1">
                 <a:solidFill>
                   <a:srgbClr val="1F497D"/>
                 </a:solidFill>
               </a:rPr>
-              <a:t>Step 2 — WAF IP Set</a:t>
-            </a:r>
-          </a:p>
-        </p:txBody>
-      </p:sp>
-      <p:sp>
-        <p:nvSpPr>
-          <p:cNvPr id="13" name="TextBox 12"/>
+              <a:t>Update IP set</a:t>
+            </a:r>
+          </a:p>
+        </p:txBody>
+      </p:sp>
+      <p:sp>
+        <p:nvSpPr>
+          <p:cNvPr id="15" name="TextBox 14"/>
           <p:cNvSpPr txBox="1"/>
           <p:nvPr/>
         </p:nvSpPr>
         <p:spPr>
           <a:xfrm>
-            <a:off x="2697480" y="3529584"/>
-            <a:ext cx="9189720" cy="603504"/>
+            <a:off x="2057400" y="4544568"/>
+            <a:ext cx="9875520" cy="621792"/>
           </a:xfrm>
           <a:prstGeom prst="rect">
             <a:avLst/>
@@ -5433,27 +5307,27 @@
           <a:p>
             <a:pPr algn="l"/>
             <a:r>
-              <a:rPr sz="950" b="0">
+              <a:rPr sz="1000" b="0">
                 <a:solidFill>
                   <a:srgbClr val="222222"/>
                 </a:solidFill>
               </a:rPr>
-              <a:t>Create an AWS WAF IP set (IPv4, scope CLOUDFRONT, us-east-1) with those CIDRs.
-    aws wafv2 create-ip-set --scope CLOUDFRONT --region us-east-1 --name mailpit-intranet-ips --ip-address-version IPV4 --addresses &lt;CIDR1&gt; &lt;CIDR2&gt;</a:t>
-            </a:r>
-          </a:p>
-        </p:txBody>
-      </p:sp>
-      <p:sp>
-        <p:nvSpPr>
-          <p:cNvPr id="14" name="Rectangle 13"/>
+              <a:t>aws wafv2 update-ip-set --scope CLOUDFRONT --region us-east-1 --name &lt;existing-ip-set-name&gt;
+    --id &lt;ip-set-id&gt; --addresses &lt;CIDR1&gt; &lt;CIDR2&gt; ... --lock-token &lt;token&gt;</a:t>
+            </a:r>
+          </a:p>
+        </p:txBody>
+      </p:sp>
+      <p:sp>
+        <p:nvSpPr>
+          <p:cNvPr id="16" name="Rectangle 15"/>
           <p:cNvSpPr/>
           <p:nvPr/>
         </p:nvSpPr>
         <p:spPr>
           <a:xfrm>
-            <a:off x="274320" y="4215384"/>
-            <a:ext cx="2286000" cy="685800"/>
+            <a:off x="274320" y="5276088"/>
+            <a:ext cx="1645920" cy="731520"/>
           </a:xfrm>
           <a:prstGeom prst="rect">
             <a:avLst/>
@@ -5491,14 +5365,14 @@
       </p:sp>
       <p:sp>
         <p:nvSpPr>
-          <p:cNvPr id="15" name="TextBox 14"/>
+          <p:cNvPr id="17" name="TextBox 16"/>
           <p:cNvSpPr txBox="1"/>
           <p:nvPr/>
         </p:nvSpPr>
         <p:spPr>
           <a:xfrm>
-            <a:off x="320040" y="4352544"/>
-            <a:ext cx="2194560" cy="438912"/>
+            <a:off x="320040" y="5458968"/>
+            <a:ext cx="1554480" cy="411480"/>
           </a:xfrm>
           <a:prstGeom prst="rect">
             <a:avLst/>
@@ -5513,26 +5387,26 @@
           <a:p>
             <a:pPr algn="ctr"/>
             <a:r>
-              <a:rPr sz="1000" b="1">
+              <a:rPr sz="1100" b="1">
                 <a:solidFill>
                   <a:srgbClr val="1F497D"/>
                 </a:solidFill>
               </a:rPr>
-              <a:t>Step 3 — WAF WebACL</a:t>
-            </a:r>
-          </a:p>
-        </p:txBody>
-      </p:sp>
-      <p:sp>
-        <p:nvSpPr>
-          <p:cNvPr id="16" name="TextBox 15"/>
+              <a:t>Verify</a:t>
+            </a:r>
+          </a:p>
+        </p:txBody>
+      </p:sp>
+      <p:sp>
+        <p:nvSpPr>
+          <p:cNvPr id="18" name="TextBox 17"/>
           <p:cNvSpPr txBox="1"/>
           <p:nvPr/>
         </p:nvSpPr>
         <p:spPr>
           <a:xfrm>
-            <a:off x="2697480" y="4288536"/>
-            <a:ext cx="9189720" cy="603504"/>
+            <a:off x="2057400" y="5367528"/>
+            <a:ext cx="9875520" cy="621792"/>
           </a:xfrm>
           <a:prstGeom prst="rect">
             <a:avLst/>
@@ -5547,76 +5421,33 @@
           <a:p>
             <a:pPr algn="l"/>
             <a:r>
-              <a:rPr sz="950" b="0">
+              <a:rPr sz="1000" b="0">
                 <a:solidFill>
                   <a:srgbClr val="222222"/>
                 </a:solidFill>
               </a:rPr>
-              <a:t>Create/update a WAF WebACL (CLOUDFRONT scope): default action = BLOCK, add an ALLOW rule matching the IP set above.</a:t>
-            </a:r>
-          </a:p>
-        </p:txBody>
-      </p:sp>
-      <p:sp>
-        <p:nvSpPr>
-          <p:cNvPr id="17" name="Rectangle 16"/>
-          <p:cNvSpPr/>
-          <p:nvPr/>
-        </p:nvSpPr>
-        <p:spPr>
-          <a:xfrm>
-            <a:off x="274320" y="4974336"/>
-            <a:ext cx="2286000" cy="685800"/>
+              <a:t>From a GSIB device: mailpit.xxx.gov.sg should load.  From a non-WOG IP: should get HTTP 403.</a:t>
+            </a:r>
+          </a:p>
+        </p:txBody>
+      </p:sp>
+      <p:sp>
+        <p:nvSpPr>
+          <p:cNvPr id="19" name="TextBox 18"/>
+          <p:cNvSpPr txBox="1"/>
+          <p:nvPr/>
+        </p:nvSpPr>
+        <p:spPr>
+          <a:xfrm>
+            <a:off x="274320" y="6199632"/>
+            <a:ext cx="11612880" cy="347472"/>
           </a:xfrm>
           <a:prstGeom prst="rect">
             <a:avLst/>
           </a:prstGeom>
           <a:solidFill>
-            <a:srgbClr val="DAE8FC"/>
+            <a:srgbClr val="FFF0E0"/>
           </a:solidFill>
-          <a:ln w="19050">
-            <a:solidFill>
-              <a:srgbClr val="6C8EBF"/>
-            </a:solidFill>
-          </a:ln>
-        </p:spPr>
-        <p:style>
-          <a:lnRef idx="1">
-            <a:schemeClr val="accent1"/>
-          </a:lnRef>
-          <a:fillRef idx="3">
-            <a:schemeClr val="accent1"/>
-          </a:fillRef>
-          <a:effectRef idx="2">
-            <a:schemeClr val="accent1"/>
-          </a:effectRef>
-          <a:fontRef idx="minor">
-            <a:schemeClr val="lt1"/>
-          </a:fontRef>
-        </p:style>
-        <p:txBody>
-          <a:bodyPr rtlCol="0" anchor="ctr"/>
-          <a:lstStyle/>
-          <a:p>
-            <a:pPr algn="ctr"/>
-          </a:p>
-        </p:txBody>
-      </p:sp>
-      <p:sp>
-        <p:nvSpPr>
-          <p:cNvPr id="18" name="TextBox 17"/>
-          <p:cNvSpPr txBox="1"/>
-          <p:nvPr/>
-        </p:nvSpPr>
-        <p:spPr>
-          <a:xfrm>
-            <a:off x="320040" y="5111496"/>
-            <a:ext cx="2194560" cy="438912"/>
-          </a:xfrm>
-          <a:prstGeom prst="rect">
-            <a:avLst/>
-          </a:prstGeom>
-          <a:noFill/>
         </p:spPr>
         <p:txBody>
           <a:bodyPr wrap="square">
@@ -5624,197 +5455,14 @@
           </a:bodyPr>
           <a:lstStyle/>
           <a:p>
-            <a:pPr algn="ctr"/>
-            <a:r>
-              <a:rPr sz="1000" b="1">
-                <a:solidFill>
-                  <a:srgbClr val="1F497D"/>
+            <a:pPr algn="l"/>
+            <a:r>
+              <a:rPr sz="1000" b="0">
+                <a:solidFill>
+                  <a:srgbClr val="992200"/>
                 </a:solidFill>
               </a:rPr>
-              <a:t>Step 4 — Attach to CloudFront</a:t>
-            </a:r>
-          </a:p>
-        </p:txBody>
-      </p:sp>
-      <p:sp>
-        <p:nvSpPr>
-          <p:cNvPr id="19" name="TextBox 18"/>
-          <p:cNvSpPr txBox="1"/>
-          <p:nvPr/>
-        </p:nvSpPr>
-        <p:spPr>
-          <a:xfrm>
-            <a:off x="2697480" y="5047488"/>
-            <a:ext cx="9189720" cy="603504"/>
-          </a:xfrm>
-          <a:prstGeom prst="rect">
-            <a:avLst/>
-          </a:prstGeom>
-          <a:noFill/>
-        </p:spPr>
-        <p:txBody>
-          <a:bodyPr wrap="square">
-            <a:spAutoFit/>
-          </a:bodyPr>
-          <a:lstStyle/>
-          <a:p>
-            <a:pPr algn="l"/>
-            <a:r>
-              <a:rPr sz="950" b="0">
-                <a:solidFill>
-                  <a:srgbClr val="222222"/>
-                </a:solidFill>
-              </a:rPr>
-              <a:t>Associate the WebACL with the Mailpit CloudFront distribution via the CloudFront console or CLI.</a:t>
-            </a:r>
-          </a:p>
-        </p:txBody>
-      </p:sp>
-      <p:sp>
-        <p:nvSpPr>
-          <p:cNvPr id="20" name="Rectangle 19"/>
-          <p:cNvSpPr/>
-          <p:nvPr/>
-        </p:nvSpPr>
-        <p:spPr>
-          <a:xfrm>
-            <a:off x="274320" y="5733288"/>
-            <a:ext cx="2286000" cy="685800"/>
-          </a:xfrm>
-          <a:prstGeom prst="rect">
-            <a:avLst/>
-          </a:prstGeom>
-          <a:solidFill>
-            <a:srgbClr val="DAE8FC"/>
-          </a:solidFill>
-          <a:ln w="19050">
-            <a:solidFill>
-              <a:srgbClr val="6C8EBF"/>
-            </a:solidFill>
-          </a:ln>
-        </p:spPr>
-        <p:style>
-          <a:lnRef idx="1">
-            <a:schemeClr val="accent1"/>
-          </a:lnRef>
-          <a:fillRef idx="3">
-            <a:schemeClr val="accent1"/>
-          </a:fillRef>
-          <a:effectRef idx="2">
-            <a:schemeClr val="accent1"/>
-          </a:effectRef>
-          <a:fontRef idx="minor">
-            <a:schemeClr val="lt1"/>
-          </a:fontRef>
-        </p:style>
-        <p:txBody>
-          <a:bodyPr rtlCol="0" anchor="ctr"/>
-          <a:lstStyle/>
-          <a:p>
-            <a:pPr algn="ctr"/>
-          </a:p>
-        </p:txBody>
-      </p:sp>
-      <p:sp>
-        <p:nvSpPr>
-          <p:cNvPr id="21" name="TextBox 20"/>
-          <p:cNvSpPr txBox="1"/>
-          <p:nvPr/>
-        </p:nvSpPr>
-        <p:spPr>
-          <a:xfrm>
-            <a:off x="320040" y="5870448"/>
-            <a:ext cx="2194560" cy="438912"/>
-          </a:xfrm>
-          <a:prstGeom prst="rect">
-            <a:avLst/>
-          </a:prstGeom>
-          <a:noFill/>
-        </p:spPr>
-        <p:txBody>
-          <a:bodyPr wrap="square">
-            <a:spAutoFit/>
-          </a:bodyPr>
-          <a:lstStyle/>
-          <a:p>
-            <a:pPr algn="ctr"/>
-            <a:r>
-              <a:rPr sz="1000" b="1">
-                <a:solidFill>
-                  <a:srgbClr val="1F497D"/>
-                </a:solidFill>
-              </a:rPr>
-              <a:t>Step 5 — Test</a:t>
-            </a:r>
-          </a:p>
-        </p:txBody>
-      </p:sp>
-      <p:sp>
-        <p:nvSpPr>
-          <p:cNvPr id="22" name="TextBox 21"/>
-          <p:cNvSpPr txBox="1"/>
-          <p:nvPr/>
-        </p:nvSpPr>
-        <p:spPr>
-          <a:xfrm>
-            <a:off x="2697480" y="5806440"/>
-            <a:ext cx="9189720" cy="603504"/>
-          </a:xfrm>
-          <a:prstGeom prst="rect">
-            <a:avLst/>
-          </a:prstGeom>
-          <a:noFill/>
-        </p:spPr>
-        <p:txBody>
-          <a:bodyPr wrap="square">
-            <a:spAutoFit/>
-          </a:bodyPr>
-          <a:lstStyle/>
-          <a:p>
-            <a:pPr algn="l"/>
-            <a:r>
-              <a:rPr sz="950" b="0">
-                <a:solidFill>
-                  <a:srgbClr val="222222"/>
-                </a:solidFill>
-              </a:rPr>
-              <a:t>From a GSIB device: should reach mailpit.xxx.gov.sg.  From a non-WOG IP: should receive HTTP 403 Forbidden.</a:t>
-            </a:r>
-          </a:p>
-        </p:txBody>
-      </p:sp>
-      <p:sp>
-        <p:nvSpPr>
-          <p:cNvPr id="23" name="TextBox 22"/>
-          <p:cNvSpPr txBox="1"/>
-          <p:nvPr/>
-        </p:nvSpPr>
-        <p:spPr>
-          <a:xfrm>
-            <a:off x="274320" y="6400800"/>
-            <a:ext cx="11612880" cy="320040"/>
-          </a:xfrm>
-          <a:prstGeom prst="rect">
-            <a:avLst/>
-          </a:prstGeom>
-          <a:solidFill>
-            <a:srgbClr val="FFF0E0"/>
-          </a:solidFill>
-        </p:spPr>
-        <p:txBody>
-          <a:bodyPr wrap="square">
-            <a:spAutoFit/>
-          </a:bodyPr>
-          <a:lstStyle/>
-          <a:p>
-            <a:pPr algn="l"/>
-            <a:r>
-              <a:rPr sz="1000" b="0">
-                <a:solidFill>
-                  <a:srgbClr val="992200"/>
-                </a:solidFill>
-              </a:rPr>
-              <a:t>Do NOT use 0.0.0.0/0 — Mailpit captures test emails that may contain sensitive data.</a:t>
+              <a:t>Do NOT open to 0.0.0.0/0 — Mailpit captures test emails that may contain sensitive data.</a:t>
             </a:r>
           </a:p>
         </p:txBody>
@@ -5909,61 +5557,27 @@
                   <a:srgbClr val="FFFFFF"/>
                 </a:solidFill>
               </a:rPr>
-              <a:t>Changes Summary (v6 vs v5)</a:t>
-            </a:r>
-          </a:p>
-        </p:txBody>
-      </p:sp>
-      <p:sp>
-        <p:nvSpPr>
-          <p:cNvPr id="4" name="TextBox 3"/>
-          <p:cNvSpPr txBox="1"/>
-          <p:nvPr/>
-        </p:nvSpPr>
-        <p:spPr>
-          <a:xfrm>
-            <a:off x="274320" y="804672"/>
-            <a:ext cx="11612880" cy="347472"/>
-          </a:xfrm>
-          <a:prstGeom prst="rect">
-            <a:avLst/>
-          </a:prstGeom>
-          <a:noFill/>
-        </p:spPr>
-        <p:txBody>
-          <a:bodyPr wrap="square">
-            <a:spAutoFit/>
-          </a:bodyPr>
-          <a:lstStyle/>
-          <a:p>
-            <a:pPr algn="l"/>
-            <a:r>
-              <a:rPr sz="1200" b="1">
-                <a:solidFill>
-                  <a:srgbClr val="1F497D"/>
-                </a:solidFill>
-              </a:rPr>
-              <a:t>What changed from v5 → v6:</a:t>
-            </a:r>
-          </a:p>
-        </p:txBody>
-      </p:sp>
-      <p:sp>
-        <p:nvSpPr>
-          <p:cNvPr id="5" name="Rectangle 4"/>
+              <a:t>Architecture Version Summary</a:t>
+            </a:r>
+          </a:p>
+        </p:txBody>
+      </p:sp>
+      <p:sp>
+        <p:nvSpPr>
+          <p:cNvPr id="4" name="Rectangle 3"/>
           <p:cNvSpPr/>
           <p:nvPr/>
         </p:nvSpPr>
         <p:spPr>
           <a:xfrm>
-            <a:off x="274320" y="1234440"/>
-            <a:ext cx="1097280" cy="594360"/>
+            <a:off x="274320" y="914400"/>
+            <a:ext cx="731520" cy="1188720"/>
           </a:xfrm>
           <a:prstGeom prst="rect">
             <a:avLst/>
           </a:prstGeom>
           <a:solidFill>
-            <a:srgbClr val="DD344C"/>
+            <a:srgbClr val="2382B8"/>
           </a:solidFill>
           <a:ln>
             <a:noFill/>
@@ -5993,14 +5607,14 @@
       </p:sp>
       <p:sp>
         <p:nvSpPr>
-          <p:cNvPr id="6" name="TextBox 5"/>
+          <p:cNvPr id="5" name="TextBox 4"/>
           <p:cNvSpPr txBox="1"/>
           <p:nvPr/>
         </p:nvSpPr>
         <p:spPr>
           <a:xfrm>
-            <a:off x="274320" y="1325880"/>
-            <a:ext cx="1097280" cy="411480"/>
+            <a:off x="274320" y="1234440"/>
+            <a:ext cx="731520" cy="502920"/>
           </a:xfrm>
           <a:prstGeom prst="rect">
             <a:avLst/>
@@ -6015,69 +5629,37 @@
           <a:p>
             <a:pPr algn="ctr"/>
             <a:r>
-              <a:rPr sz="1100" b="1">
+              <a:rPr sz="2200" b="1">
                 <a:solidFill>
                   <a:srgbClr val="FFFFFF"/>
                 </a:solidFill>
               </a:rPr>
-              <a:t>REMOVED</a:t>
-            </a:r>
-          </a:p>
-        </p:txBody>
-      </p:sp>
-      <p:sp>
-        <p:nvSpPr>
-          <p:cNvPr id="7" name="TextBox 6"/>
-          <p:cNvSpPr txBox="1"/>
-          <p:nvPr/>
-        </p:nvSpPr>
-        <p:spPr>
-          <a:xfrm>
-            <a:off x="1508760" y="1325880"/>
-            <a:ext cx="10424160" cy="502920"/>
-          </a:xfrm>
-          <a:prstGeom prst="rect">
-            <a:avLst/>
-          </a:prstGeom>
-          <a:noFill/>
-        </p:spPr>
-        <p:txBody>
-          <a:bodyPr wrap="square">
-            <a:spAutoFit/>
-          </a:bodyPr>
-          <a:lstStyle/>
-          <a:p>
-            <a:pPr algn="l"/>
-            <a:r>
-              <a:rPr sz="1050" b="0">
-                <a:solidFill>
-                  <a:srgbClr val="222222"/>
-                </a:solidFill>
-              </a:rPr>
-              <a:t>Mailpit ALB — not needed; CloudFront supports direct EC2 custom origin</a:t>
-            </a:r>
-          </a:p>
-        </p:txBody>
-      </p:sp>
-      <p:sp>
-        <p:nvSpPr>
-          <p:cNvPr id="8" name="Rectangle 7"/>
+              <a:t>v5</a:t>
+            </a:r>
+          </a:p>
+        </p:txBody>
+      </p:sp>
+      <p:sp>
+        <p:nvSpPr>
+          <p:cNvPr id="6" name="Rectangle 5"/>
           <p:cNvSpPr/>
           <p:nvPr/>
         </p:nvSpPr>
         <p:spPr>
           <a:xfrm>
-            <a:off x="274320" y="1993392"/>
-            <a:ext cx="1097280" cy="594360"/>
+            <a:off x="1143000" y="914400"/>
+            <a:ext cx="1280160" cy="1188720"/>
           </a:xfrm>
           <a:prstGeom prst="rect">
             <a:avLst/>
           </a:prstGeom>
           <a:solidFill>
-            <a:srgbClr val="DD344C"/>
+            <a:srgbClr val="EEEEEE"/>
           </a:solidFill>
-          <a:ln>
-            <a:noFill/>
+          <a:ln w="19050">
+            <a:solidFill>
+              <a:srgbClr val="2382B8"/>
+            </a:solidFill>
           </a:ln>
         </p:spPr>
         <p:style>
@@ -6104,14 +5686,14 @@
       </p:sp>
       <p:sp>
         <p:nvSpPr>
-          <p:cNvPr id="9" name="TextBox 8"/>
+          <p:cNvPr id="7" name="TextBox 6"/>
           <p:cNvSpPr txBox="1"/>
           <p:nvPr/>
         </p:nvSpPr>
         <p:spPr>
           <a:xfrm>
-            <a:off x="274320" y="2084832"/>
-            <a:ext cx="1097280" cy="411480"/>
+            <a:off x="1188720" y="1234440"/>
+            <a:ext cx="1188720" cy="502920"/>
           </a:xfrm>
           <a:prstGeom prst="rect">
             <a:avLst/>
@@ -6126,26 +5708,26 @@
           <a:p>
             <a:pPr algn="ctr"/>
             <a:r>
-              <a:rPr sz="1100" b="1">
-                <a:solidFill>
-                  <a:srgbClr val="FFFFFF"/>
+              <a:rPr sz="1400" b="1">
+                <a:solidFill>
+                  <a:srgbClr val="2382B8"/>
                 </a:solidFill>
               </a:rPr>
-              <a:t>REMOVED</a:t>
-            </a:r>
-          </a:p>
-        </p:txBody>
-      </p:sp>
-      <p:sp>
-        <p:nvSpPr>
-          <p:cNvPr id="10" name="TextBox 9"/>
+              <a:t>Added</a:t>
+            </a:r>
+          </a:p>
+        </p:txBody>
+      </p:sp>
+      <p:sp>
+        <p:nvSpPr>
+          <p:cNvPr id="8" name="TextBox 7"/>
           <p:cNvSpPr txBox="1"/>
           <p:nvPr/>
         </p:nvSpPr>
         <p:spPr>
           <a:xfrm>
-            <a:off x="1508760" y="2084832"/>
-            <a:ext cx="10424160" cy="502920"/>
+            <a:off x="2560320" y="1234440"/>
+            <a:ext cx="9326880" cy="548640"/>
           </a:xfrm>
           <a:prstGeom prst="rect">
             <a:avLst/>
@@ -6160,26 +5742,26 @@
           <a:p>
             <a:pPr algn="l"/>
             <a:r>
-              <a:rPr sz="1050" b="0">
+              <a:rPr sz="1100" b="0">
                 <a:solidFill>
                   <a:srgbClr val="222222"/>
                 </a:solidFill>
               </a:rPr>
-              <a:t>ALB → EC2 edge and ALB security group rule</a:t>
-            </a:r>
-          </a:p>
-        </p:txBody>
-      </p:sp>
-      <p:sp>
-        <p:nvSpPr>
-          <p:cNvPr id="11" name="Rectangle 10"/>
+              <a:t>CloudFront, Route 53, WOG Domain, WAF (dedicated), ALB, Mailpit flow arrows</a:t>
+            </a:r>
+          </a:p>
+        </p:txBody>
+      </p:sp>
+      <p:sp>
+        <p:nvSpPr>
+          <p:cNvPr id="9" name="Rectangle 8"/>
           <p:cNvSpPr/>
           <p:nvPr/>
         </p:nvSpPr>
         <p:spPr>
           <a:xfrm>
-            <a:off x="274320" y="2752344"/>
-            <a:ext cx="1097280" cy="594360"/>
+            <a:off x="274320" y="2286000"/>
+            <a:ext cx="731520" cy="1188720"/>
           </a:xfrm>
           <a:prstGeom prst="rect">
             <a:avLst/>
@@ -6215,14 +5797,14 @@
       </p:sp>
       <p:sp>
         <p:nvSpPr>
-          <p:cNvPr id="12" name="TextBox 11"/>
+          <p:cNvPr id="10" name="TextBox 9"/>
           <p:cNvSpPr txBox="1"/>
           <p:nvPr/>
         </p:nvSpPr>
         <p:spPr>
           <a:xfrm>
-            <a:off x="274320" y="2843784"/>
-            <a:ext cx="1097280" cy="411480"/>
+            <a:off x="274320" y="2606040"/>
+            <a:ext cx="731520" cy="502920"/>
           </a:xfrm>
           <a:prstGeom prst="rect">
             <a:avLst/>
@@ -6237,69 +5819,37 @@
           <a:p>
             <a:pPr algn="ctr"/>
             <a:r>
-              <a:rPr sz="1100" b="1">
+              <a:rPr sz="2200" b="1">
                 <a:solidFill>
                   <a:srgbClr val="FFFFFF"/>
                 </a:solidFill>
               </a:rPr>
-              <a:t>UPDATED</a:t>
-            </a:r>
-          </a:p>
-        </p:txBody>
-      </p:sp>
-      <p:sp>
-        <p:nvSpPr>
-          <p:cNvPr id="13" name="TextBox 12"/>
-          <p:cNvSpPr txBox="1"/>
-          <p:nvPr/>
-        </p:nvSpPr>
-        <p:spPr>
-          <a:xfrm>
-            <a:off x="1508760" y="2843784"/>
-            <a:ext cx="10424160" cy="502920"/>
-          </a:xfrm>
-          <a:prstGeom prst="rect">
-            <a:avLst/>
-          </a:prstGeom>
-          <a:noFill/>
-        </p:spPr>
-        <p:txBody>
-          <a:bodyPr wrap="square">
-            <a:spAutoFit/>
-          </a:bodyPr>
-          <a:lstStyle/>
-          <a:p>
-            <a:pPr algn="l"/>
-            <a:r>
-              <a:rPr sz="1050" b="0">
-                <a:solidFill>
-                  <a:srgbClr val="222222"/>
-                </a:solidFill>
-              </a:rPr>
-              <a:t>CloudFront now wired directly to Mailpit EC2 Elastic IP (port 8025)</a:t>
-            </a:r>
-          </a:p>
-        </p:txBody>
-      </p:sp>
-      <p:sp>
-        <p:nvSpPr>
-          <p:cNvPr id="14" name="Rectangle 13"/>
+              <a:t>v6</a:t>
+            </a:r>
+          </a:p>
+        </p:txBody>
+      </p:sp>
+      <p:sp>
+        <p:nvSpPr>
+          <p:cNvPr id="11" name="Rectangle 10"/>
           <p:cNvSpPr/>
           <p:nvPr/>
         </p:nvSpPr>
         <p:spPr>
           <a:xfrm>
-            <a:off x="274320" y="3511296"/>
-            <a:ext cx="1097280" cy="594360"/>
+            <a:off x="1143000" y="2286000"/>
+            <a:ext cx="1280160" cy="1188720"/>
           </a:xfrm>
           <a:prstGeom prst="rect">
             <a:avLst/>
           </a:prstGeom>
           <a:solidFill>
-            <a:srgbClr val="D86613"/>
+            <a:srgbClr val="EEEEEE"/>
           </a:solidFill>
-          <a:ln>
-            <a:noFill/>
+          <a:ln w="19050">
+            <a:solidFill>
+              <a:srgbClr val="D86613"/>
+            </a:solidFill>
           </a:ln>
         </p:spPr>
         <p:style>
@@ -6326,14 +5876,14 @@
       </p:sp>
       <p:sp>
         <p:nvSpPr>
-          <p:cNvPr id="15" name="TextBox 14"/>
+          <p:cNvPr id="12" name="TextBox 11"/>
           <p:cNvSpPr txBox="1"/>
           <p:nvPr/>
         </p:nvSpPr>
         <p:spPr>
           <a:xfrm>
-            <a:off x="274320" y="3602736"/>
-            <a:ext cx="1097280" cy="411480"/>
+            <a:off x="1188720" y="2606040"/>
+            <a:ext cx="1188720" cy="502920"/>
           </a:xfrm>
           <a:prstGeom prst="rect">
             <a:avLst/>
@@ -6348,26 +5898,26 @@
           <a:p>
             <a:pPr algn="ctr"/>
             <a:r>
-              <a:rPr sz="1100" b="1">
-                <a:solidFill>
-                  <a:srgbClr val="FFFFFF"/>
+              <a:rPr sz="1400" b="1">
+                <a:solidFill>
+                  <a:srgbClr val="D86613"/>
                 </a:solidFill>
               </a:rPr>
-              <a:t>UPDATED</a:t>
-            </a:r>
-          </a:p>
-        </p:txBody>
-      </p:sp>
-      <p:sp>
-        <p:nvSpPr>
-          <p:cNvPr id="16" name="TextBox 15"/>
+              <a:t>Removed</a:t>
+            </a:r>
+          </a:p>
+        </p:txBody>
+      </p:sp>
+      <p:sp>
+        <p:nvSpPr>
+          <p:cNvPr id="13" name="TextBox 12"/>
           <p:cNvSpPr txBox="1"/>
           <p:nvPr/>
         </p:nvSpPr>
         <p:spPr>
           <a:xfrm>
-            <a:off x="1508760" y="3602736"/>
-            <a:ext cx="10424160" cy="502920"/>
+            <a:off x="2560320" y="2606040"/>
+            <a:ext cx="9326880" cy="548640"/>
           </a:xfrm>
           <a:prstGeom prst="rect">
             <a:avLst/>
@@ -6382,137 +5932,26 @@
           <a:p>
             <a:pPr algn="l"/>
             <a:r>
-              <a:rPr sz="1050" b="0">
+              <a:rPr sz="1100" b="0">
                 <a:solidFill>
                   <a:srgbClr val="222222"/>
                 </a:solidFill>
               </a:rPr>
-              <a:t>CloudFormation template: replaced AllowedCidr for port 8025 with CloudFront managed prefix list (SourcePrefixListId) — prevents bypassing WAF via direct IP access</a:t>
-            </a:r>
-          </a:p>
-        </p:txBody>
-      </p:sp>
-      <p:sp>
-        <p:nvSpPr>
-          <p:cNvPr id="17" name="Rectangle 16"/>
+              <a:t>ALB — not needed; CloudFront connects directly to Mailpit EC2 (EIP:8025)</a:t>
+            </a:r>
+          </a:p>
+        </p:txBody>
+      </p:sp>
+      <p:sp>
+        <p:nvSpPr>
+          <p:cNvPr id="14" name="Rectangle 13"/>
           <p:cNvSpPr/>
           <p:nvPr/>
         </p:nvSpPr>
         <p:spPr>
           <a:xfrm>
-            <a:off x="274320" y="4270248"/>
-            <a:ext cx="1097280" cy="594360"/>
-          </a:xfrm>
-          <a:prstGeom prst="rect">
-            <a:avLst/>
-          </a:prstGeom>
-          <a:solidFill>
-            <a:srgbClr val="D86613"/>
-          </a:solidFill>
-          <a:ln>
-            <a:noFill/>
-          </a:ln>
-        </p:spPr>
-        <p:style>
-          <a:lnRef idx="1">
-            <a:schemeClr val="accent1"/>
-          </a:lnRef>
-          <a:fillRef idx="3">
-            <a:schemeClr val="accent1"/>
-          </a:fillRef>
-          <a:effectRef idx="2">
-            <a:schemeClr val="accent1"/>
-          </a:effectRef>
-          <a:fontRef idx="minor">
-            <a:schemeClr val="lt1"/>
-          </a:fontRef>
-        </p:style>
-        <p:txBody>
-          <a:bodyPr rtlCol="0" anchor="ctr"/>
-          <a:lstStyle/>
-          <a:p>
-            <a:pPr algn="ctr"/>
-          </a:p>
-        </p:txBody>
-      </p:sp>
-      <p:sp>
-        <p:nvSpPr>
-          <p:cNvPr id="18" name="TextBox 17"/>
-          <p:cNvSpPr txBox="1"/>
-          <p:nvPr/>
-        </p:nvSpPr>
-        <p:spPr>
-          <a:xfrm>
-            <a:off x="274320" y="4361688"/>
-            <a:ext cx="1097280" cy="411480"/>
-          </a:xfrm>
-          <a:prstGeom prst="rect">
-            <a:avLst/>
-          </a:prstGeom>
-          <a:noFill/>
-        </p:spPr>
-        <p:txBody>
-          <a:bodyPr wrap="square">
-            <a:spAutoFit/>
-          </a:bodyPr>
-          <a:lstStyle/>
-          <a:p>
-            <a:pPr algn="ctr"/>
-            <a:r>
-              <a:rPr sz="1100" b="1">
-                <a:solidFill>
-                  <a:srgbClr val="FFFFFF"/>
-                </a:solidFill>
-              </a:rPr>
-              <a:t>UPDATED</a:t>
-            </a:r>
-          </a:p>
-        </p:txBody>
-      </p:sp>
-      <p:sp>
-        <p:nvSpPr>
-          <p:cNvPr id="19" name="TextBox 18"/>
-          <p:cNvSpPr txBox="1"/>
-          <p:nvPr/>
-        </p:nvSpPr>
-        <p:spPr>
-          <a:xfrm>
-            <a:off x="1508760" y="4361688"/>
-            <a:ext cx="10424160" cy="502920"/>
-          </a:xfrm>
-          <a:prstGeom prst="rect">
-            <a:avLst/>
-          </a:prstGeom>
-          <a:noFill/>
-        </p:spPr>
-        <p:txBody>
-          <a:bodyPr wrap="square">
-            <a:spAutoFit/>
-          </a:bodyPr>
-          <a:lstStyle/>
-          <a:p>
-            <a:pPr algn="l"/>
-            <a:r>
-              <a:rPr sz="1050" b="0">
-                <a:solidFill>
-                  <a:srgbClr val="222222"/>
-                </a:solidFill>
-              </a:rPr>
-              <a:t>Firewall rule note: CloudFront prefix list → EC2:8025 (no ALB hop)</a:t>
-            </a:r>
-          </a:p>
-        </p:txBody>
-      </p:sp>
-      <p:sp>
-        <p:nvSpPr>
-          <p:cNvPr id="20" name="Rectangle 19"/>
-          <p:cNvSpPr/>
-          <p:nvPr/>
-        </p:nvSpPr>
-        <p:spPr>
-          <a:xfrm>
-            <a:off x="274320" y="5029200"/>
-            <a:ext cx="1097280" cy="594360"/>
+            <a:off x="274320" y="3657600"/>
+            <a:ext cx="731520" cy="1188720"/>
           </a:xfrm>
           <a:prstGeom prst="rect">
             <a:avLst/>
@@ -6548,14 +5987,14 @@
       </p:sp>
       <p:sp>
         <p:nvSpPr>
-          <p:cNvPr id="21" name="TextBox 20"/>
+          <p:cNvPr id="15" name="TextBox 14"/>
           <p:cNvSpPr txBox="1"/>
           <p:nvPr/>
         </p:nvSpPr>
         <p:spPr>
           <a:xfrm>
-            <a:off x="274320" y="5120640"/>
-            <a:ext cx="1097280" cy="411480"/>
+            <a:off x="274320" y="3977639"/>
+            <a:ext cx="731520" cy="502920"/>
           </a:xfrm>
           <a:prstGeom prst="rect">
             <a:avLst/>
@@ -6570,26 +6009,71 @@
           <a:p>
             <a:pPr algn="ctr"/>
             <a:r>
-              <a:rPr sz="1100" b="1">
+              <a:rPr sz="2200" b="1">
                 <a:solidFill>
                   <a:srgbClr val="FFFFFF"/>
                 </a:solidFill>
               </a:rPr>
-              <a:t>ADDED</a:t>
-            </a:r>
-          </a:p>
-        </p:txBody>
-      </p:sp>
-      <p:sp>
-        <p:nvSpPr>
-          <p:cNvPr id="22" name="TextBox 21"/>
+              <a:t>v7</a:t>
+            </a:r>
+          </a:p>
+        </p:txBody>
+      </p:sp>
+      <p:sp>
+        <p:nvSpPr>
+          <p:cNvPr id="16" name="Rectangle 15"/>
+          <p:cNvSpPr/>
+          <p:nvPr/>
+        </p:nvSpPr>
+        <p:spPr>
+          <a:xfrm>
+            <a:off x="1143000" y="3657600"/>
+            <a:ext cx="1280160" cy="1188720"/>
+          </a:xfrm>
+          <a:prstGeom prst="rect">
+            <a:avLst/>
+          </a:prstGeom>
+          <a:solidFill>
+            <a:srgbClr val="EEEEEE"/>
+          </a:solidFill>
+          <a:ln w="19050">
+            <a:solidFill>
+              <a:srgbClr val="248814"/>
+            </a:solidFill>
+          </a:ln>
+        </p:spPr>
+        <p:style>
+          <a:lnRef idx="1">
+            <a:schemeClr val="accent1"/>
+          </a:lnRef>
+          <a:fillRef idx="3">
+            <a:schemeClr val="accent1"/>
+          </a:fillRef>
+          <a:effectRef idx="2">
+            <a:schemeClr val="accent1"/>
+          </a:effectRef>
+          <a:fontRef idx="minor">
+            <a:schemeClr val="lt1"/>
+          </a:fontRef>
+        </p:style>
+        <p:txBody>
+          <a:bodyPr rtlCol="0" anchor="ctr"/>
+          <a:lstStyle/>
+          <a:p>
+            <a:pPr algn="ctr"/>
+          </a:p>
+        </p:txBody>
+      </p:sp>
+      <p:sp>
+        <p:nvSpPr>
+          <p:cNvPr id="17" name="TextBox 16"/>
           <p:cNvSpPr txBox="1"/>
           <p:nvPr/>
         </p:nvSpPr>
         <p:spPr>
           <a:xfrm>
-            <a:off x="1508760" y="5120640"/>
-            <a:ext cx="10424160" cy="502920"/>
+            <a:off x="1188720" y="3977639"/>
+            <a:ext cx="1188720" cy="502920"/>
           </a:xfrm>
           <a:prstGeom prst="rect">
             <a:avLst/>
@@ -6602,28 +6086,28 @@
           </a:bodyPr>
           <a:lstStyle/>
           <a:p>
-            <a:pPr algn="l"/>
-            <a:r>
-              <a:rPr sz="1050" b="0">
-                <a:solidFill>
-                  <a:srgbClr val="222222"/>
+            <a:pPr algn="ctr"/>
+            <a:r>
+              <a:rPr sz="1400" b="1">
+                <a:solidFill>
+                  <a:srgbClr val="248814"/>
                 </a:solidFill>
               </a:rPr>
-              <a:t>EC2 Security Group explanation (port 8025 = CloudFront prefix list only; port 1025 = internal CIDR for app servers)</a:t>
-            </a:r>
-          </a:p>
-        </p:txBody>
-      </p:sp>
-      <p:sp>
-        <p:nvSpPr>
-          <p:cNvPr id="23" name="TextBox 22"/>
+              <a:t>Updated</a:t>
+            </a:r>
+          </a:p>
+        </p:txBody>
+      </p:sp>
+      <p:sp>
+        <p:nvSpPr>
+          <p:cNvPr id="18" name="TextBox 17"/>
           <p:cNvSpPr txBox="1"/>
           <p:nvPr/>
         </p:nvSpPr>
         <p:spPr>
           <a:xfrm>
-            <a:off x="274320" y="6035040"/>
-            <a:ext cx="11612880" cy="502920"/>
+            <a:off x="2560320" y="3977639"/>
+            <a:ext cx="9326880" cy="548640"/>
           </a:xfrm>
           <a:prstGeom prst="rect">
             <a:avLst/>
@@ -6638,12 +6122,127 @@
           <a:p>
             <a:pPr algn="l"/>
             <a:r>
-              <a:rPr sz="1100" b="1">
+              <a:rPr sz="1100" b="0">
+                <a:solidFill>
+                  <a:srgbClr val="222222"/>
+                </a:solidFill>
+              </a:rPr>
+              <a:t>WAF — replaced dedicated Mailpit WAF with shared existing WAF WebACL (same one used by court CDNs)</a:t>
+            </a:r>
+          </a:p>
+        </p:txBody>
+      </p:sp>
+      <p:sp>
+        <p:nvSpPr>
+          <p:cNvPr id="19" name="TextBox 18"/>
+          <p:cNvSpPr txBox="1"/>
+          <p:nvPr/>
+        </p:nvSpPr>
+        <p:spPr>
+          <a:xfrm>
+            <a:off x="274320" y="5120640"/>
+            <a:ext cx="11612880" cy="320040"/>
+          </a:xfrm>
+          <a:prstGeom prst="rect">
+            <a:avLst/>
+          </a:prstGeom>
+          <a:noFill/>
+        </p:spPr>
+        <p:txBody>
+          <a:bodyPr wrap="square">
+            <a:spAutoFit/>
+          </a:bodyPr>
+          <a:lstStyle/>
+          <a:p>
+            <a:pPr algn="l"/>
+            <a:r>
+              <a:rPr sz="1200" b="1">
                 <a:solidFill>
                   <a:srgbClr val="1F497D"/>
                 </a:solidFill>
               </a:rPr>
-              <a:t>Result: simpler architecture, ~$25/month cheaper (no ALB), same security posture via WAF + SG prefix list.</a:t>
+              <a:t>Current architecture (v7) — final flow:</a:t>
+            </a:r>
+          </a:p>
+        </p:txBody>
+      </p:sp>
+      <p:sp>
+        <p:nvSpPr>
+          <p:cNvPr id="20" name="Rectangle 19"/>
+          <p:cNvSpPr/>
+          <p:nvPr/>
+        </p:nvSpPr>
+        <p:spPr>
+          <a:xfrm>
+            <a:off x="274320" y="5486400"/>
+            <a:ext cx="11612880" cy="1051560"/>
+          </a:xfrm>
+          <a:prstGeom prst="rect">
+            <a:avLst/>
+          </a:prstGeom>
+          <a:solidFill>
+            <a:srgbClr val="DAE8FC"/>
+          </a:solidFill>
+          <a:ln w="19050">
+            <a:solidFill>
+              <a:srgbClr val="6C8EBF"/>
+            </a:solidFill>
+          </a:ln>
+        </p:spPr>
+        <p:style>
+          <a:lnRef idx="1">
+            <a:schemeClr val="accent1"/>
+          </a:lnRef>
+          <a:fillRef idx="3">
+            <a:schemeClr val="accent1"/>
+          </a:fillRef>
+          <a:effectRef idx="2">
+            <a:schemeClr val="accent1"/>
+          </a:effectRef>
+          <a:fontRef idx="minor">
+            <a:schemeClr val="lt1"/>
+          </a:fontRef>
+        </p:style>
+        <p:txBody>
+          <a:bodyPr rtlCol="0" anchor="ctr"/>
+          <a:lstStyle/>
+          <a:p>
+            <a:pPr algn="ctr"/>
+          </a:p>
+        </p:txBody>
+      </p:sp>
+      <p:sp>
+        <p:nvSpPr>
+          <p:cNvPr id="21" name="TextBox 20"/>
+          <p:cNvSpPr txBox="1"/>
+          <p:nvPr/>
+        </p:nvSpPr>
+        <p:spPr>
+          <a:xfrm>
+            <a:off x="365760" y="5532120"/>
+            <a:ext cx="11430000" cy="960120"/>
+          </a:xfrm>
+          <a:prstGeom prst="rect">
+            <a:avLst/>
+          </a:prstGeom>
+          <a:noFill/>
+        </p:spPr>
+        <p:txBody>
+          <a:bodyPr wrap="square">
+            <a:spAutoFit/>
+          </a:bodyPr>
+          <a:lstStyle/>
+          <a:p>
+            <a:pPr algn="l"/>
+            <a:r>
+              <a:rPr sz="1100" b="0">
+                <a:solidFill>
+                  <a:srgbClr val="1F497D"/>
+                </a:solidFill>
+              </a:rPr>
+              <a:t>GSIB Notebook  →  WOG Domain  →  Route 53  →  CloudFront (Mailpit CDN)
+  → [Existing WAF WebACL — shared with court CDNs, WOG IP allowlist]
+  → EC2 Security Group (port 8025, CloudFront prefix list only)  →  Mailpit EC2 (EIP:8025)</a:t>
             </a:r>
           </a:p>
         </p:txBody>

</xml_diff>